<commit_message>
UPdated graph theory notes
</commit_message>
<xml_diff>
--- a/u09a_graphTheory/notes/3 Matrix Multiplication/Matrix Multiplication.pptx
+++ b/u09a_graphTheory/notes/3 Matrix Multiplication/Matrix Multiplication.pptx
@@ -3887,600 +3887,699 @@
           </a:p>
         </p:txBody>
       </p:sp>
-      <p:graphicFrame>
-        <p:nvGraphicFramePr>
-          <p:cNvPr id="5124" name="Object 4">
+      <p:grpSp>
+        <p:nvGrpSpPr>
+          <p:cNvPr id="2" name="Group 1" descr="-2 * [7 -1 0] = [-14 2 0]">
             <a:extLst>
               <a:ext uri="{FF2B5EF4-FFF2-40B4-BE49-F238E27FC236}">
-                <a16:creationId xmlns:a16="http://schemas.microsoft.com/office/drawing/2014/main" id="{149A5B58-4354-43C2-B696-B4E4B7F0026E}"/>
+                <a16:creationId xmlns:a16="http://schemas.microsoft.com/office/drawing/2014/main" id="{FF3D6FB7-1CC8-7B47-D8D5-5BBCFF35CE9C}"/>
               </a:ext>
             </a:extLst>
           </p:cNvPr>
-          <p:cNvGraphicFramePr>
-            <a:graphicFrameLocks noChangeAspect="1"/>
-          </p:cNvGraphicFramePr>
+          <p:cNvGrpSpPr/>
           <p:nvPr/>
-        </p:nvGraphicFramePr>
-        <p:xfrm>
-          <a:off x="609600" y="2057400"/>
-          <a:ext cx="3886200" cy="698500"/>
-        </p:xfrm>
-        <a:graphic>
-          <a:graphicData uri="http://schemas.openxmlformats.org/presentationml/2006/ole">
-            <mc:AlternateContent xmlns:mc="http://schemas.openxmlformats.org/markup-compatibility/2006">
-              <mc:Choice xmlns:v="urn:schemas-microsoft-com:vml" Requires="v">
-                <p:oleObj name="Equation" r:id="rId2" imgW="1130300" imgH="203200" progId="Equation.DSMT36">
-                  <p:embed/>
-                </p:oleObj>
-              </mc:Choice>
-              <mc:Fallback>
-                <p:oleObj name="Equation" r:id="rId2" imgW="1130300" imgH="203200" progId="Equation.DSMT36">
-                  <p:embed/>
-                  <p:pic>
-                    <p:nvPicPr>
-                      <p:cNvPr id="0" name="Object 4"/>
-                      <p:cNvPicPr>
-                        <a:picLocks noChangeAspect="1" noChangeArrowheads="1"/>
-                      </p:cNvPicPr>
-                      <p:nvPr/>
-                    </p:nvPicPr>
-                    <p:blipFill>
-                      <a:blip r:embed="rId3">
+        </p:nvGrpSpPr>
+        <p:grpSpPr>
+          <a:xfrm>
+            <a:off x="609600" y="2057400"/>
+            <a:ext cx="7467600" cy="698500"/>
+            <a:chOff x="609600" y="2057400"/>
+            <a:chExt cx="7467600" cy="698500"/>
+          </a:xfrm>
+        </p:grpSpPr>
+        <p:graphicFrame>
+          <p:nvGraphicFramePr>
+            <p:cNvPr id="5124" name="Object 4">
+              <a:extLst>
+                <a:ext uri="{FF2B5EF4-FFF2-40B4-BE49-F238E27FC236}">
+                  <a16:creationId xmlns:a16="http://schemas.microsoft.com/office/drawing/2014/main" id="{149A5B58-4354-43C2-B696-B4E4B7F0026E}"/>
+                </a:ext>
+              </a:extLst>
+            </p:cNvPr>
+            <p:cNvGraphicFramePr>
+              <a:graphicFrameLocks noChangeAspect="1"/>
+            </p:cNvGraphicFramePr>
+            <p:nvPr>
+              <p:extLst>
+                <p:ext uri="{D42A27DB-BD31-4B8C-83A1-F6EECF244321}">
+                  <p14:modId xmlns:p14="http://schemas.microsoft.com/office/powerpoint/2010/main" val="1448711926"/>
+                </p:ext>
+              </p:extLst>
+            </p:nvPr>
+          </p:nvGraphicFramePr>
+          <p:xfrm>
+            <a:off x="609600" y="2057400"/>
+            <a:ext cx="3886200" cy="698500"/>
+          </p:xfrm>
+          <a:graphic>
+            <a:graphicData uri="http://schemas.openxmlformats.org/presentationml/2006/ole">
+              <mc:AlternateContent xmlns:mc="http://schemas.openxmlformats.org/markup-compatibility/2006">
+                <mc:Choice xmlns:v="urn:schemas-microsoft-com:vml" Requires="v">
+                  <p:oleObj name="Equation" r:id="rId2" imgW="1130300" imgH="203200" progId="Equation.DSMT36">
+                    <p:embed/>
+                  </p:oleObj>
+                </mc:Choice>
+                <mc:Fallback>
+                  <p:oleObj name="Equation" r:id="rId2" imgW="1130300" imgH="203200" progId="Equation.DSMT36">
+                    <p:embed/>
+                    <p:pic>
+                      <p:nvPicPr>
+                        <p:cNvPr id="0" name="Object 4"/>
+                        <p:cNvPicPr>
+                          <a:picLocks noChangeAspect="1" noChangeArrowheads="1"/>
+                        </p:cNvPicPr>
+                        <p:nvPr/>
+                      </p:nvPicPr>
+                      <p:blipFill>
+                        <a:blip r:embed="rId3">
+                          <a:extLst>
+                            <a:ext uri="{28A0092B-C50C-407E-A947-70E740481C1C}">
+                              <a14:useLocalDpi xmlns:a14="http://schemas.microsoft.com/office/drawing/2010/main" val="0"/>
+                            </a:ext>
+                          </a:extLst>
+                        </a:blip>
+                        <a:srcRect/>
+                        <a:stretch>
+                          <a:fillRect/>
+                        </a:stretch>
+                      </p:blipFill>
+                      <p:spPr bwMode="auto">
+                        <a:xfrm>
+                          <a:off x="609600" y="2057400"/>
+                          <a:ext cx="3886200" cy="698500"/>
+                        </a:xfrm>
+                        <a:prstGeom prst="rect">
+                          <a:avLst/>
+                        </a:prstGeom>
+                        <a:noFill/>
+                        <a:ln>
+                          <a:noFill/>
+                        </a:ln>
+                        <a:effectLst/>
                         <a:extLst>
-                          <a:ext uri="{28A0092B-C50C-407E-A947-70E740481C1C}">
-                            <a14:useLocalDpi xmlns:a14="http://schemas.microsoft.com/office/drawing/2010/main" val="0"/>
+                          <a:ext uri="{909E8E84-426E-40DD-AFC4-6F175D3DCCD1}">
+                            <a14:hiddenFill xmlns:a14="http://schemas.microsoft.com/office/drawing/2010/main">
+                              <a:solidFill>
+                                <a:schemeClr val="accent1"/>
+                              </a:solidFill>
+                            </a14:hiddenFill>
+                          </a:ext>
+                          <a:ext uri="{91240B29-F687-4F45-9708-019B960494DF}">
+                            <a14:hiddenLine xmlns:a14="http://schemas.microsoft.com/office/drawing/2010/main" w="9525">
+                              <a:solidFill>
+                                <a:schemeClr val="tx1"/>
+                              </a:solidFill>
+                              <a:miter lim="800000"/>
+                              <a:headEnd/>
+                              <a:tailEnd/>
+                            </a14:hiddenLine>
+                          </a:ext>
+                          <a:ext uri="{AF507438-7753-43E0-B8FC-AC1667EBCBE1}">
+                            <a14:hiddenEffects xmlns:a14="http://schemas.microsoft.com/office/drawing/2010/main">
+                              <a:effectLst>
+                                <a:outerShdw dist="35921" dir="2700000" algn="ctr" rotWithShape="0">
+                                  <a:schemeClr val="bg2"/>
+                                </a:outerShdw>
+                              </a:effectLst>
+                            </a14:hiddenEffects>
                           </a:ext>
                         </a:extLst>
-                      </a:blip>
-                      <a:srcRect/>
-                      <a:stretch>
-                        <a:fillRect/>
-                      </a:stretch>
-                    </p:blipFill>
-                    <p:spPr bwMode="auto">
-                      <a:xfrm>
-                        <a:off x="609600" y="2057400"/>
-                        <a:ext cx="3886200" cy="698500"/>
-                      </a:xfrm>
-                      <a:prstGeom prst="rect">
-                        <a:avLst/>
-                      </a:prstGeom>
-                      <a:noFill/>
-                      <a:ln>
+                      </p:spPr>
+                    </p:pic>
+                  </p:oleObj>
+                </mc:Fallback>
+              </mc:AlternateContent>
+            </a:graphicData>
+          </a:graphic>
+        </p:graphicFrame>
+        <p:graphicFrame>
+          <p:nvGraphicFramePr>
+            <p:cNvPr id="5126" name="Object 6">
+              <a:extLst>
+                <a:ext uri="{FF2B5EF4-FFF2-40B4-BE49-F238E27FC236}">
+                  <a16:creationId xmlns:a16="http://schemas.microsoft.com/office/drawing/2014/main" id="{EDD25223-E731-4902-8EA6-A80F085C10C6}"/>
+                </a:ext>
+              </a:extLst>
+            </p:cNvPr>
+            <p:cNvGraphicFramePr>
+              <a:graphicFrameLocks noChangeAspect="1"/>
+            </p:cNvGraphicFramePr>
+            <p:nvPr>
+              <p:extLst>
+                <p:ext uri="{D42A27DB-BD31-4B8C-83A1-F6EECF244321}">
+                  <p14:modId xmlns:p14="http://schemas.microsoft.com/office/powerpoint/2010/main" val="4180299394"/>
+                </p:ext>
+              </p:extLst>
+            </p:nvPr>
+          </p:nvGraphicFramePr>
+          <p:xfrm>
+            <a:off x="4724400" y="2057400"/>
+            <a:ext cx="3352800" cy="696913"/>
+          </p:xfrm>
+          <a:graphic>
+            <a:graphicData uri="http://schemas.openxmlformats.org/presentationml/2006/ole">
+              <mc:AlternateContent xmlns:mc="http://schemas.openxmlformats.org/markup-compatibility/2006">
+                <mc:Choice xmlns:v="urn:schemas-microsoft-com:vml" Requires="v">
+                  <p:oleObj name="Equation" r:id="rId4" imgW="977900" imgH="203200" progId="Equation.DSMT36">
+                    <p:embed/>
+                  </p:oleObj>
+                </mc:Choice>
+                <mc:Fallback>
+                  <p:oleObj name="Equation" r:id="rId4" imgW="977900" imgH="203200" progId="Equation.DSMT36">
+                    <p:embed/>
+                    <p:pic>
+                      <p:nvPicPr>
+                        <p:cNvPr id="0" name="Object 6"/>
+                        <p:cNvPicPr>
+                          <a:picLocks noChangeAspect="1" noChangeArrowheads="1"/>
+                        </p:cNvPicPr>
+                        <p:nvPr/>
+                      </p:nvPicPr>
+                      <p:blipFill>
+                        <a:blip r:embed="rId5">
+                          <a:extLst>
+                            <a:ext uri="{28A0092B-C50C-407E-A947-70E740481C1C}">
+                              <a14:useLocalDpi xmlns:a14="http://schemas.microsoft.com/office/drawing/2010/main" val="0"/>
+                            </a:ext>
+                          </a:extLst>
+                        </a:blip>
+                        <a:srcRect/>
+                        <a:stretch>
+                          <a:fillRect/>
+                        </a:stretch>
+                      </p:blipFill>
+                      <p:spPr bwMode="auto">
+                        <a:xfrm>
+                          <a:off x="4724400" y="2057400"/>
+                          <a:ext cx="3352800" cy="696913"/>
+                        </a:xfrm>
+                        <a:prstGeom prst="rect">
+                          <a:avLst/>
+                        </a:prstGeom>
                         <a:noFill/>
-                      </a:ln>
-                      <a:effectLst/>
-                      <a:extLst>
-                        <a:ext uri="{909E8E84-426E-40DD-AFC4-6F175D3DCCD1}">
-                          <a14:hiddenFill xmlns:a14="http://schemas.microsoft.com/office/drawing/2010/main">
-                            <a:solidFill>
-                              <a:schemeClr val="accent1"/>
-                            </a:solidFill>
-                          </a14:hiddenFill>
-                        </a:ext>
-                        <a:ext uri="{91240B29-F687-4F45-9708-019B960494DF}">
-                          <a14:hiddenLine xmlns:a14="http://schemas.microsoft.com/office/drawing/2010/main" w="9525">
-                            <a:solidFill>
-                              <a:schemeClr val="tx1"/>
-                            </a:solidFill>
-                            <a:miter lim="800000"/>
-                            <a:headEnd/>
-                            <a:tailEnd/>
-                          </a14:hiddenLine>
-                        </a:ext>
-                        <a:ext uri="{AF507438-7753-43E0-B8FC-AC1667EBCBE1}">
-                          <a14:hiddenEffects xmlns:a14="http://schemas.microsoft.com/office/drawing/2010/main">
-                            <a:effectLst>
-                              <a:outerShdw dist="35921" dir="2700000" algn="ctr" rotWithShape="0">
-                                <a:schemeClr val="bg2"/>
-                              </a:outerShdw>
-                            </a:effectLst>
-                          </a14:hiddenEffects>
-                        </a:ext>
-                      </a:extLst>
-                    </p:spPr>
-                  </p:pic>
-                </p:oleObj>
-              </mc:Fallback>
-            </mc:AlternateContent>
-          </a:graphicData>
-        </a:graphic>
-      </p:graphicFrame>
-      <p:graphicFrame>
-        <p:nvGraphicFramePr>
-          <p:cNvPr id="5126" name="Object 6">
-            <a:extLst>
-              <a:ext uri="{FF2B5EF4-FFF2-40B4-BE49-F238E27FC236}">
-                <a16:creationId xmlns:a16="http://schemas.microsoft.com/office/drawing/2014/main" id="{EDD25223-E731-4902-8EA6-A80F085C10C6}"/>
-              </a:ext>
-            </a:extLst>
-          </p:cNvPr>
-          <p:cNvGraphicFramePr>
-            <a:graphicFrameLocks noChangeAspect="1"/>
-          </p:cNvGraphicFramePr>
-          <p:nvPr/>
-        </p:nvGraphicFramePr>
-        <p:xfrm>
-          <a:off x="4724400" y="2057400"/>
-          <a:ext cx="3352800" cy="696913"/>
-        </p:xfrm>
-        <a:graphic>
-          <a:graphicData uri="http://schemas.openxmlformats.org/presentationml/2006/ole">
-            <mc:AlternateContent xmlns:mc="http://schemas.openxmlformats.org/markup-compatibility/2006">
-              <mc:Choice xmlns:v="urn:schemas-microsoft-com:vml" Requires="v">
-                <p:oleObj name="Equation" r:id="rId4" imgW="977900" imgH="203200" progId="Equation.DSMT36">
-                  <p:embed/>
-                </p:oleObj>
-              </mc:Choice>
-              <mc:Fallback>
-                <p:oleObj name="Equation" r:id="rId4" imgW="977900" imgH="203200" progId="Equation.DSMT36">
-                  <p:embed/>
-                  <p:pic>
-                    <p:nvPicPr>
-                      <p:cNvPr id="0" name="Object 6"/>
-                      <p:cNvPicPr>
-                        <a:picLocks noChangeAspect="1" noChangeArrowheads="1"/>
-                      </p:cNvPicPr>
-                      <p:nvPr/>
-                    </p:nvPicPr>
-                    <p:blipFill>
-                      <a:blip r:embed="rId5">
+                        <a:ln>
+                          <a:noFill/>
+                        </a:ln>
+                        <a:effectLst/>
                         <a:extLst>
-                          <a:ext uri="{28A0092B-C50C-407E-A947-70E740481C1C}">
-                            <a14:useLocalDpi xmlns:a14="http://schemas.microsoft.com/office/drawing/2010/main" val="0"/>
+                          <a:ext uri="{909E8E84-426E-40DD-AFC4-6F175D3DCCD1}">
+                            <a14:hiddenFill xmlns:a14="http://schemas.microsoft.com/office/drawing/2010/main">
+                              <a:solidFill>
+                                <a:srgbClr val="FFFFFF"/>
+                              </a:solidFill>
+                            </a14:hiddenFill>
+                          </a:ext>
+                          <a:ext uri="{91240B29-F687-4F45-9708-019B960494DF}">
+                            <a14:hiddenLine xmlns:a14="http://schemas.microsoft.com/office/drawing/2010/main" w="9525">
+                              <a:solidFill>
+                                <a:srgbClr val="000000"/>
+                              </a:solidFill>
+                              <a:miter lim="800000"/>
+                              <a:headEnd/>
+                              <a:tailEnd/>
+                            </a14:hiddenLine>
+                          </a:ext>
+                          <a:ext uri="{AF507438-7753-43E0-B8FC-AC1667EBCBE1}">
+                            <a14:hiddenEffects xmlns:a14="http://schemas.microsoft.com/office/drawing/2010/main">
+                              <a:effectLst>
+                                <a:outerShdw dist="35921" dir="2700000" algn="ctr" rotWithShape="0">
+                                  <a:srgbClr val="808080"/>
+                                </a:outerShdw>
+                              </a:effectLst>
+                            </a14:hiddenEffects>
                           </a:ext>
                         </a:extLst>
-                      </a:blip>
-                      <a:srcRect/>
-                      <a:stretch>
-                        <a:fillRect/>
-                      </a:stretch>
-                    </p:blipFill>
-                    <p:spPr bwMode="auto">
-                      <a:xfrm>
-                        <a:off x="4724400" y="2057400"/>
-                        <a:ext cx="3352800" cy="696913"/>
-                      </a:xfrm>
-                      <a:prstGeom prst="rect">
-                        <a:avLst/>
-                      </a:prstGeom>
-                      <a:noFill/>
-                      <a:ln>
+                      </p:spPr>
+                    </p:pic>
+                  </p:oleObj>
+                </mc:Fallback>
+              </mc:AlternateContent>
+            </a:graphicData>
+          </a:graphic>
+        </p:graphicFrame>
+      </p:grpSp>
+      <p:grpSp>
+        <p:nvGrpSpPr>
+          <p:cNvPr id="3" name="Group 2">
+            <a:extLst>
+              <a:ext uri="{FF2B5EF4-FFF2-40B4-BE49-F238E27FC236}">
+                <a16:creationId xmlns:a16="http://schemas.microsoft.com/office/drawing/2014/main" id="{E5192015-6A7A-688F-8F7C-58F38696C4D9}"/>
+              </a:ext>
+            </a:extLst>
+          </p:cNvPr>
+          <p:cNvGrpSpPr/>
+          <p:nvPr/>
+        </p:nvGrpSpPr>
+        <p:grpSpPr>
+          <a:xfrm>
+            <a:off x="609600" y="3276600"/>
+            <a:ext cx="6146800" cy="1439863"/>
+            <a:chOff x="609600" y="3276600"/>
+            <a:chExt cx="6146800" cy="1439863"/>
+          </a:xfrm>
+        </p:grpSpPr>
+        <p:graphicFrame>
+          <p:nvGraphicFramePr>
+            <p:cNvPr id="5127" name="Object 7">
+              <a:extLst>
+                <a:ext uri="{FF2B5EF4-FFF2-40B4-BE49-F238E27FC236}">
+                  <a16:creationId xmlns:a16="http://schemas.microsoft.com/office/drawing/2014/main" id="{C40946A8-F0CD-4C79-AC6A-6C6961B6A7CF}"/>
+                </a:ext>
+              </a:extLst>
+            </p:cNvPr>
+            <p:cNvGraphicFramePr>
+              <a:graphicFrameLocks noChangeAspect="1"/>
+            </p:cNvGraphicFramePr>
+            <p:nvPr>
+              <p:extLst>
+                <p:ext uri="{D42A27DB-BD31-4B8C-83A1-F6EECF244321}">
+                  <p14:modId xmlns:p14="http://schemas.microsoft.com/office/powerpoint/2010/main" val="500244023"/>
+                </p:ext>
+              </p:extLst>
+            </p:nvPr>
+          </p:nvGraphicFramePr>
+          <p:xfrm>
+            <a:off x="609600" y="3276600"/>
+            <a:ext cx="3048000" cy="1439863"/>
+          </p:xfrm>
+          <a:graphic>
+            <a:graphicData uri="http://schemas.openxmlformats.org/presentationml/2006/ole">
+              <mc:AlternateContent xmlns:mc="http://schemas.openxmlformats.org/markup-compatibility/2006">
+                <mc:Choice xmlns:v="urn:schemas-microsoft-com:vml" Requires="v">
+                  <p:oleObj name="Equation" r:id="rId6" imgW="914400" imgH="431800" progId="Equation.DSMT36">
+                    <p:embed/>
+                  </p:oleObj>
+                </mc:Choice>
+                <mc:Fallback>
+                  <p:oleObj name="Equation" r:id="rId6" imgW="914400" imgH="431800" progId="Equation.DSMT36">
+                    <p:embed/>
+                    <p:pic>
+                      <p:nvPicPr>
+                        <p:cNvPr id="0" name="Object 7"/>
+                        <p:cNvPicPr>
+                          <a:picLocks noChangeAspect="1" noChangeArrowheads="1"/>
+                        </p:cNvPicPr>
+                        <p:nvPr/>
+                      </p:nvPicPr>
+                      <p:blipFill>
+                        <a:blip r:embed="rId7">
+                          <a:extLst>
+                            <a:ext uri="{28A0092B-C50C-407E-A947-70E740481C1C}">
+                              <a14:useLocalDpi xmlns:a14="http://schemas.microsoft.com/office/drawing/2010/main" val="0"/>
+                            </a:ext>
+                          </a:extLst>
+                        </a:blip>
+                        <a:srcRect/>
+                        <a:stretch>
+                          <a:fillRect/>
+                        </a:stretch>
+                      </p:blipFill>
+                      <p:spPr bwMode="auto">
+                        <a:xfrm>
+                          <a:off x="609600" y="3276600"/>
+                          <a:ext cx="3048000" cy="1439863"/>
+                        </a:xfrm>
+                        <a:prstGeom prst="rect">
+                          <a:avLst/>
+                        </a:prstGeom>
                         <a:noFill/>
-                      </a:ln>
-                      <a:effectLst/>
-                      <a:extLst>
-                        <a:ext uri="{909E8E84-426E-40DD-AFC4-6F175D3DCCD1}">
-                          <a14:hiddenFill xmlns:a14="http://schemas.microsoft.com/office/drawing/2010/main">
-                            <a:solidFill>
-                              <a:srgbClr val="FFFFFF"/>
-                            </a:solidFill>
-                          </a14:hiddenFill>
-                        </a:ext>
-                        <a:ext uri="{91240B29-F687-4F45-9708-019B960494DF}">
-                          <a14:hiddenLine xmlns:a14="http://schemas.microsoft.com/office/drawing/2010/main" w="9525">
-                            <a:solidFill>
-                              <a:srgbClr val="000000"/>
-                            </a:solidFill>
-                            <a:miter lim="800000"/>
-                            <a:headEnd/>
-                            <a:tailEnd/>
-                          </a14:hiddenLine>
-                        </a:ext>
-                        <a:ext uri="{AF507438-7753-43E0-B8FC-AC1667EBCBE1}">
-                          <a14:hiddenEffects xmlns:a14="http://schemas.microsoft.com/office/drawing/2010/main">
-                            <a:effectLst>
-                              <a:outerShdw dist="35921" dir="2700000" algn="ctr" rotWithShape="0">
-                                <a:srgbClr val="808080"/>
-                              </a:outerShdw>
-                            </a:effectLst>
-                          </a14:hiddenEffects>
-                        </a:ext>
-                      </a:extLst>
-                    </p:spPr>
-                  </p:pic>
-                </p:oleObj>
-              </mc:Fallback>
-            </mc:AlternateContent>
-          </a:graphicData>
-        </a:graphic>
-      </p:graphicFrame>
-      <p:graphicFrame>
-        <p:nvGraphicFramePr>
-          <p:cNvPr id="5127" name="Object 7">
-            <a:extLst>
-              <a:ext uri="{FF2B5EF4-FFF2-40B4-BE49-F238E27FC236}">
-                <a16:creationId xmlns:a16="http://schemas.microsoft.com/office/drawing/2014/main" id="{C40946A8-F0CD-4C79-AC6A-6C6961B6A7CF}"/>
-              </a:ext>
-            </a:extLst>
-          </p:cNvPr>
-          <p:cNvGraphicFramePr>
-            <a:graphicFrameLocks noChangeAspect="1"/>
-          </p:cNvGraphicFramePr>
-          <p:nvPr/>
-        </p:nvGraphicFramePr>
-        <p:xfrm>
-          <a:off x="609600" y="3276600"/>
-          <a:ext cx="3048000" cy="1439863"/>
-        </p:xfrm>
-        <a:graphic>
-          <a:graphicData uri="http://schemas.openxmlformats.org/presentationml/2006/ole">
-            <mc:AlternateContent xmlns:mc="http://schemas.openxmlformats.org/markup-compatibility/2006">
-              <mc:Choice xmlns:v="urn:schemas-microsoft-com:vml" Requires="v">
-                <p:oleObj name="Equation" r:id="rId6" imgW="914400" imgH="431800" progId="Equation.DSMT36">
-                  <p:embed/>
-                </p:oleObj>
-              </mc:Choice>
-              <mc:Fallback>
-                <p:oleObj name="Equation" r:id="rId6" imgW="914400" imgH="431800" progId="Equation.DSMT36">
-                  <p:embed/>
-                  <p:pic>
-                    <p:nvPicPr>
-                      <p:cNvPr id="0" name="Object 7"/>
-                      <p:cNvPicPr>
-                        <a:picLocks noChangeAspect="1" noChangeArrowheads="1"/>
-                      </p:cNvPicPr>
-                      <p:nvPr/>
-                    </p:nvPicPr>
-                    <p:blipFill>
-                      <a:blip r:embed="rId7">
+                        <a:ln>
+                          <a:noFill/>
+                        </a:ln>
+                        <a:effectLst/>
                         <a:extLst>
-                          <a:ext uri="{28A0092B-C50C-407E-A947-70E740481C1C}">
-                            <a14:useLocalDpi xmlns:a14="http://schemas.microsoft.com/office/drawing/2010/main" val="0"/>
+                          <a:ext uri="{909E8E84-426E-40DD-AFC4-6F175D3DCCD1}">
+                            <a14:hiddenFill xmlns:a14="http://schemas.microsoft.com/office/drawing/2010/main">
+                              <a:solidFill>
+                                <a:schemeClr val="accent1"/>
+                              </a:solidFill>
+                            </a14:hiddenFill>
+                          </a:ext>
+                          <a:ext uri="{91240B29-F687-4F45-9708-019B960494DF}">
+                            <a14:hiddenLine xmlns:a14="http://schemas.microsoft.com/office/drawing/2010/main" w="9525">
+                              <a:solidFill>
+                                <a:schemeClr val="tx1"/>
+                              </a:solidFill>
+                              <a:miter lim="800000"/>
+                              <a:headEnd/>
+                              <a:tailEnd/>
+                            </a14:hiddenLine>
+                          </a:ext>
+                          <a:ext uri="{AF507438-7753-43E0-B8FC-AC1667EBCBE1}">
+                            <a14:hiddenEffects xmlns:a14="http://schemas.microsoft.com/office/drawing/2010/main">
+                              <a:effectLst>
+                                <a:outerShdw dist="35921" dir="2700000" algn="ctr" rotWithShape="0">
+                                  <a:schemeClr val="bg2"/>
+                                </a:outerShdw>
+                              </a:effectLst>
+                            </a14:hiddenEffects>
                           </a:ext>
                         </a:extLst>
-                      </a:blip>
-                      <a:srcRect/>
-                      <a:stretch>
-                        <a:fillRect/>
-                      </a:stretch>
-                    </p:blipFill>
-                    <p:spPr bwMode="auto">
-                      <a:xfrm>
-                        <a:off x="609600" y="3276600"/>
-                        <a:ext cx="3048000" cy="1439863"/>
-                      </a:xfrm>
-                      <a:prstGeom prst="rect">
-                        <a:avLst/>
-                      </a:prstGeom>
-                      <a:noFill/>
-                      <a:ln>
+                      </p:spPr>
+                    </p:pic>
+                  </p:oleObj>
+                </mc:Fallback>
+              </mc:AlternateContent>
+            </a:graphicData>
+          </a:graphic>
+        </p:graphicFrame>
+        <p:graphicFrame>
+          <p:nvGraphicFramePr>
+            <p:cNvPr id="5128" name="Object 8">
+              <a:extLst>
+                <a:ext uri="{FF2B5EF4-FFF2-40B4-BE49-F238E27FC236}">
+                  <a16:creationId xmlns:a16="http://schemas.microsoft.com/office/drawing/2014/main" id="{820E626D-C165-4F6F-97C9-DD762C719FFC}"/>
+                </a:ext>
+              </a:extLst>
+            </p:cNvPr>
+            <p:cNvGraphicFramePr>
+              <a:graphicFrameLocks noChangeAspect="1"/>
+            </p:cNvGraphicFramePr>
+            <p:nvPr>
+              <p:extLst>
+                <p:ext uri="{D42A27DB-BD31-4B8C-83A1-F6EECF244321}">
+                  <p14:modId xmlns:p14="http://schemas.microsoft.com/office/powerpoint/2010/main" val="2543691511"/>
+                </p:ext>
+              </p:extLst>
+            </p:nvPr>
+          </p:nvGraphicFramePr>
+          <p:xfrm>
+            <a:off x="4038600" y="3276600"/>
+            <a:ext cx="2717800" cy="1358900"/>
+          </p:xfrm>
+          <a:graphic>
+            <a:graphicData uri="http://schemas.openxmlformats.org/presentationml/2006/ole">
+              <mc:AlternateContent xmlns:mc="http://schemas.openxmlformats.org/markup-compatibility/2006">
+                <mc:Choice xmlns:v="urn:schemas-microsoft-com:vml" Requires="v">
+                  <p:oleObj name="Equation" r:id="rId8" imgW="863600" imgH="431800" progId="Equation.DSMT36">
+                    <p:embed/>
+                  </p:oleObj>
+                </mc:Choice>
+                <mc:Fallback>
+                  <p:oleObj name="Equation" r:id="rId8" imgW="863600" imgH="431800" progId="Equation.DSMT36">
+                    <p:embed/>
+                    <p:pic>
+                      <p:nvPicPr>
+                        <p:cNvPr id="0" name="Object 8"/>
+                        <p:cNvPicPr>
+                          <a:picLocks noChangeAspect="1" noChangeArrowheads="1"/>
+                        </p:cNvPicPr>
+                        <p:nvPr/>
+                      </p:nvPicPr>
+                      <p:blipFill>
+                        <a:blip r:embed="rId9">
+                          <a:extLst>
+                            <a:ext uri="{28A0092B-C50C-407E-A947-70E740481C1C}">
+                              <a14:useLocalDpi xmlns:a14="http://schemas.microsoft.com/office/drawing/2010/main" val="0"/>
+                            </a:ext>
+                          </a:extLst>
+                        </a:blip>
+                        <a:srcRect/>
+                        <a:stretch>
+                          <a:fillRect/>
+                        </a:stretch>
+                      </p:blipFill>
+                      <p:spPr bwMode="auto">
+                        <a:xfrm>
+                          <a:off x="4038600" y="3276600"/>
+                          <a:ext cx="2717800" cy="1358900"/>
+                        </a:xfrm>
+                        <a:prstGeom prst="rect">
+                          <a:avLst/>
+                        </a:prstGeom>
                         <a:noFill/>
-                      </a:ln>
-                      <a:effectLst/>
-                      <a:extLst>
-                        <a:ext uri="{909E8E84-426E-40DD-AFC4-6F175D3DCCD1}">
-                          <a14:hiddenFill xmlns:a14="http://schemas.microsoft.com/office/drawing/2010/main">
-                            <a:solidFill>
-                              <a:schemeClr val="accent1"/>
-                            </a:solidFill>
-                          </a14:hiddenFill>
-                        </a:ext>
-                        <a:ext uri="{91240B29-F687-4F45-9708-019B960494DF}">
-                          <a14:hiddenLine xmlns:a14="http://schemas.microsoft.com/office/drawing/2010/main" w="9525">
-                            <a:solidFill>
-                              <a:schemeClr val="tx1"/>
-                            </a:solidFill>
-                            <a:miter lim="800000"/>
-                            <a:headEnd/>
-                            <a:tailEnd/>
-                          </a14:hiddenLine>
-                        </a:ext>
-                        <a:ext uri="{AF507438-7753-43E0-B8FC-AC1667EBCBE1}">
-                          <a14:hiddenEffects xmlns:a14="http://schemas.microsoft.com/office/drawing/2010/main">
-                            <a:effectLst>
-                              <a:outerShdw dist="35921" dir="2700000" algn="ctr" rotWithShape="0">
-                                <a:schemeClr val="bg2"/>
-                              </a:outerShdw>
-                            </a:effectLst>
-                          </a14:hiddenEffects>
-                        </a:ext>
-                      </a:extLst>
-                    </p:spPr>
-                  </p:pic>
-                </p:oleObj>
-              </mc:Fallback>
-            </mc:AlternateContent>
-          </a:graphicData>
-        </a:graphic>
-      </p:graphicFrame>
-      <p:graphicFrame>
-        <p:nvGraphicFramePr>
-          <p:cNvPr id="5128" name="Object 8">
-            <a:extLst>
-              <a:ext uri="{FF2B5EF4-FFF2-40B4-BE49-F238E27FC236}">
-                <a16:creationId xmlns:a16="http://schemas.microsoft.com/office/drawing/2014/main" id="{820E626D-C165-4F6F-97C9-DD762C719FFC}"/>
-              </a:ext>
-            </a:extLst>
-          </p:cNvPr>
-          <p:cNvGraphicFramePr>
-            <a:graphicFrameLocks noChangeAspect="1"/>
-          </p:cNvGraphicFramePr>
-          <p:nvPr/>
-        </p:nvGraphicFramePr>
-        <p:xfrm>
-          <a:off x="4038600" y="3276600"/>
-          <a:ext cx="2717800" cy="1358900"/>
-        </p:xfrm>
-        <a:graphic>
-          <a:graphicData uri="http://schemas.openxmlformats.org/presentationml/2006/ole">
-            <mc:AlternateContent xmlns:mc="http://schemas.openxmlformats.org/markup-compatibility/2006">
-              <mc:Choice xmlns:v="urn:schemas-microsoft-com:vml" Requires="v">
-                <p:oleObj name="Equation" r:id="rId8" imgW="863600" imgH="431800" progId="Equation.DSMT36">
-                  <p:embed/>
-                </p:oleObj>
-              </mc:Choice>
-              <mc:Fallback>
-                <p:oleObj name="Equation" r:id="rId8" imgW="863600" imgH="431800" progId="Equation.DSMT36">
-                  <p:embed/>
-                  <p:pic>
-                    <p:nvPicPr>
-                      <p:cNvPr id="0" name="Object 8"/>
-                      <p:cNvPicPr>
-                        <a:picLocks noChangeAspect="1" noChangeArrowheads="1"/>
-                      </p:cNvPicPr>
-                      <p:nvPr/>
-                    </p:nvPicPr>
-                    <p:blipFill>
-                      <a:blip r:embed="rId9">
+                        <a:ln>
+                          <a:noFill/>
+                        </a:ln>
+                        <a:effectLst/>
                         <a:extLst>
-                          <a:ext uri="{28A0092B-C50C-407E-A947-70E740481C1C}">
-                            <a14:useLocalDpi xmlns:a14="http://schemas.microsoft.com/office/drawing/2010/main" val="0"/>
+                          <a:ext uri="{909E8E84-426E-40DD-AFC4-6F175D3DCCD1}">
+                            <a14:hiddenFill xmlns:a14="http://schemas.microsoft.com/office/drawing/2010/main">
+                              <a:solidFill>
+                                <a:srgbClr val="FFFFFF"/>
+                              </a:solidFill>
+                            </a14:hiddenFill>
+                          </a:ext>
+                          <a:ext uri="{91240B29-F687-4F45-9708-019B960494DF}">
+                            <a14:hiddenLine xmlns:a14="http://schemas.microsoft.com/office/drawing/2010/main" w="9525">
+                              <a:solidFill>
+                                <a:srgbClr val="000000"/>
+                              </a:solidFill>
+                              <a:miter lim="800000"/>
+                              <a:headEnd/>
+                              <a:tailEnd/>
+                            </a14:hiddenLine>
+                          </a:ext>
+                          <a:ext uri="{AF507438-7753-43E0-B8FC-AC1667EBCBE1}">
+                            <a14:hiddenEffects xmlns:a14="http://schemas.microsoft.com/office/drawing/2010/main">
+                              <a:effectLst>
+                                <a:outerShdw dist="35921" dir="2700000" algn="ctr" rotWithShape="0">
+                                  <a:srgbClr val="808080"/>
+                                </a:outerShdw>
+                              </a:effectLst>
+                            </a14:hiddenEffects>
                           </a:ext>
                         </a:extLst>
-                      </a:blip>
-                      <a:srcRect/>
-                      <a:stretch>
-                        <a:fillRect/>
-                      </a:stretch>
-                    </p:blipFill>
-                    <p:spPr bwMode="auto">
-                      <a:xfrm>
-                        <a:off x="4038600" y="3276600"/>
-                        <a:ext cx="2717800" cy="1358900"/>
-                      </a:xfrm>
-                      <a:prstGeom prst="rect">
-                        <a:avLst/>
-                      </a:prstGeom>
-                      <a:noFill/>
-                      <a:ln>
+                      </p:spPr>
+                    </p:pic>
+                  </p:oleObj>
+                </mc:Fallback>
+              </mc:AlternateContent>
+            </a:graphicData>
+          </a:graphic>
+        </p:graphicFrame>
+      </p:grpSp>
+      <p:grpSp>
+        <p:nvGrpSpPr>
+          <p:cNvPr id="4" name="Group 3">
+            <a:extLst>
+              <a:ext uri="{FF2B5EF4-FFF2-40B4-BE49-F238E27FC236}">
+                <a16:creationId xmlns:a16="http://schemas.microsoft.com/office/drawing/2014/main" id="{1969A527-2DBB-E940-3ECF-B5555AC2FAEC}"/>
+              </a:ext>
+            </a:extLst>
+          </p:cNvPr>
+          <p:cNvGrpSpPr/>
+          <p:nvPr/>
+        </p:nvGrpSpPr>
+        <p:grpSpPr>
+          <a:xfrm>
+            <a:off x="533400" y="4953000"/>
+            <a:ext cx="7315200" cy="1682750"/>
+            <a:chOff x="533400" y="4953000"/>
+            <a:chExt cx="7315200" cy="1682750"/>
+          </a:xfrm>
+        </p:grpSpPr>
+        <p:graphicFrame>
+          <p:nvGraphicFramePr>
+            <p:cNvPr id="5129" name="Object 9">
+              <a:extLst>
+                <a:ext uri="{FF2B5EF4-FFF2-40B4-BE49-F238E27FC236}">
+                  <a16:creationId xmlns:a16="http://schemas.microsoft.com/office/drawing/2014/main" id="{2BD1880B-F6CF-4C2A-8B24-78ABE3666805}"/>
+                </a:ext>
+              </a:extLst>
+            </p:cNvPr>
+            <p:cNvGraphicFramePr>
+              <a:graphicFrameLocks noChangeAspect="1"/>
+            </p:cNvGraphicFramePr>
+            <p:nvPr>
+              <p:extLst>
+                <p:ext uri="{D42A27DB-BD31-4B8C-83A1-F6EECF244321}">
+                  <p14:modId xmlns:p14="http://schemas.microsoft.com/office/powerpoint/2010/main" val="2654995722"/>
+                </p:ext>
+              </p:extLst>
+            </p:nvPr>
+          </p:nvGraphicFramePr>
+          <p:xfrm>
+            <a:off x="533400" y="4953000"/>
+            <a:ext cx="3429000" cy="1682750"/>
+          </p:xfrm>
+          <a:graphic>
+            <a:graphicData uri="http://schemas.openxmlformats.org/presentationml/2006/ole">
+              <mc:AlternateContent xmlns:mc="http://schemas.openxmlformats.org/markup-compatibility/2006">
+                <mc:Choice xmlns:v="urn:schemas-microsoft-com:vml" Requires="v">
+                  <p:oleObj name="Equation" r:id="rId10" imgW="1346200" imgH="660400" progId="Equation.DSMT36">
+                    <p:embed/>
+                  </p:oleObj>
+                </mc:Choice>
+                <mc:Fallback>
+                  <p:oleObj name="Equation" r:id="rId10" imgW="1346200" imgH="660400" progId="Equation.DSMT36">
+                    <p:embed/>
+                    <p:pic>
+                      <p:nvPicPr>
+                        <p:cNvPr id="0" name="Object 9"/>
+                        <p:cNvPicPr>
+                          <a:picLocks noChangeAspect="1" noChangeArrowheads="1"/>
+                        </p:cNvPicPr>
+                        <p:nvPr/>
+                      </p:nvPicPr>
+                      <p:blipFill>
+                        <a:blip r:embed="rId11">
+                          <a:extLst>
+                            <a:ext uri="{28A0092B-C50C-407E-A947-70E740481C1C}">
+                              <a14:useLocalDpi xmlns:a14="http://schemas.microsoft.com/office/drawing/2010/main" val="0"/>
+                            </a:ext>
+                          </a:extLst>
+                        </a:blip>
+                        <a:srcRect/>
+                        <a:stretch>
+                          <a:fillRect/>
+                        </a:stretch>
+                      </p:blipFill>
+                      <p:spPr bwMode="auto">
+                        <a:xfrm>
+                          <a:off x="533400" y="4953000"/>
+                          <a:ext cx="3429000" cy="1682750"/>
+                        </a:xfrm>
+                        <a:prstGeom prst="rect">
+                          <a:avLst/>
+                        </a:prstGeom>
                         <a:noFill/>
-                      </a:ln>
-                      <a:effectLst/>
-                      <a:extLst>
-                        <a:ext uri="{909E8E84-426E-40DD-AFC4-6F175D3DCCD1}">
-                          <a14:hiddenFill xmlns:a14="http://schemas.microsoft.com/office/drawing/2010/main">
-                            <a:solidFill>
-                              <a:srgbClr val="FFFFFF"/>
-                            </a:solidFill>
-                          </a14:hiddenFill>
-                        </a:ext>
-                        <a:ext uri="{91240B29-F687-4F45-9708-019B960494DF}">
-                          <a14:hiddenLine xmlns:a14="http://schemas.microsoft.com/office/drawing/2010/main" w="9525">
-                            <a:solidFill>
-                              <a:srgbClr val="000000"/>
-                            </a:solidFill>
-                            <a:miter lim="800000"/>
-                            <a:headEnd/>
-                            <a:tailEnd/>
-                          </a14:hiddenLine>
-                        </a:ext>
-                        <a:ext uri="{AF507438-7753-43E0-B8FC-AC1667EBCBE1}">
-                          <a14:hiddenEffects xmlns:a14="http://schemas.microsoft.com/office/drawing/2010/main">
-                            <a:effectLst>
-                              <a:outerShdw dist="35921" dir="2700000" algn="ctr" rotWithShape="0">
-                                <a:srgbClr val="808080"/>
-                              </a:outerShdw>
-                            </a:effectLst>
-                          </a14:hiddenEffects>
-                        </a:ext>
-                      </a:extLst>
-                    </p:spPr>
-                  </p:pic>
-                </p:oleObj>
-              </mc:Fallback>
-            </mc:AlternateContent>
-          </a:graphicData>
-        </a:graphic>
-      </p:graphicFrame>
-      <p:graphicFrame>
-        <p:nvGraphicFramePr>
-          <p:cNvPr id="5129" name="Object 9">
-            <a:extLst>
-              <a:ext uri="{FF2B5EF4-FFF2-40B4-BE49-F238E27FC236}">
-                <a16:creationId xmlns:a16="http://schemas.microsoft.com/office/drawing/2014/main" id="{2BD1880B-F6CF-4C2A-8B24-78ABE3666805}"/>
-              </a:ext>
-            </a:extLst>
-          </p:cNvPr>
-          <p:cNvGraphicFramePr>
-            <a:graphicFrameLocks noChangeAspect="1"/>
-          </p:cNvGraphicFramePr>
-          <p:nvPr/>
-        </p:nvGraphicFramePr>
-        <p:xfrm>
-          <a:off x="533400" y="4953000"/>
-          <a:ext cx="3429000" cy="1682750"/>
-        </p:xfrm>
-        <a:graphic>
-          <a:graphicData uri="http://schemas.openxmlformats.org/presentationml/2006/ole">
-            <mc:AlternateContent xmlns:mc="http://schemas.openxmlformats.org/markup-compatibility/2006">
-              <mc:Choice xmlns:v="urn:schemas-microsoft-com:vml" Requires="v">
-                <p:oleObj name="Equation" r:id="rId10" imgW="1346200" imgH="660400" progId="Equation.DSMT36">
-                  <p:embed/>
-                </p:oleObj>
-              </mc:Choice>
-              <mc:Fallback>
-                <p:oleObj name="Equation" r:id="rId10" imgW="1346200" imgH="660400" progId="Equation.DSMT36">
-                  <p:embed/>
-                  <p:pic>
-                    <p:nvPicPr>
-                      <p:cNvPr id="0" name="Object 9"/>
-                      <p:cNvPicPr>
-                        <a:picLocks noChangeAspect="1" noChangeArrowheads="1"/>
-                      </p:cNvPicPr>
-                      <p:nvPr/>
-                    </p:nvPicPr>
-                    <p:blipFill>
-                      <a:blip r:embed="rId11">
+                        <a:ln>
+                          <a:noFill/>
+                        </a:ln>
+                        <a:effectLst/>
                         <a:extLst>
-                          <a:ext uri="{28A0092B-C50C-407E-A947-70E740481C1C}">
-                            <a14:useLocalDpi xmlns:a14="http://schemas.microsoft.com/office/drawing/2010/main" val="0"/>
+                          <a:ext uri="{909E8E84-426E-40DD-AFC4-6F175D3DCCD1}">
+                            <a14:hiddenFill xmlns:a14="http://schemas.microsoft.com/office/drawing/2010/main">
+                              <a:solidFill>
+                                <a:schemeClr val="accent1"/>
+                              </a:solidFill>
+                            </a14:hiddenFill>
+                          </a:ext>
+                          <a:ext uri="{91240B29-F687-4F45-9708-019B960494DF}">
+                            <a14:hiddenLine xmlns:a14="http://schemas.microsoft.com/office/drawing/2010/main" w="9525">
+                              <a:solidFill>
+                                <a:schemeClr val="tx1"/>
+                              </a:solidFill>
+                              <a:miter lim="800000"/>
+                              <a:headEnd/>
+                              <a:tailEnd/>
+                            </a14:hiddenLine>
+                          </a:ext>
+                          <a:ext uri="{AF507438-7753-43E0-B8FC-AC1667EBCBE1}">
+                            <a14:hiddenEffects xmlns:a14="http://schemas.microsoft.com/office/drawing/2010/main">
+                              <a:effectLst>
+                                <a:outerShdw dist="35921" dir="2700000" algn="ctr" rotWithShape="0">
+                                  <a:schemeClr val="bg2"/>
+                                </a:outerShdw>
+                              </a:effectLst>
+                            </a14:hiddenEffects>
                           </a:ext>
                         </a:extLst>
-                      </a:blip>
-                      <a:srcRect/>
-                      <a:stretch>
-                        <a:fillRect/>
-                      </a:stretch>
-                    </p:blipFill>
-                    <p:spPr bwMode="auto">
-                      <a:xfrm>
-                        <a:off x="533400" y="4953000"/>
-                        <a:ext cx="3429000" cy="1682750"/>
-                      </a:xfrm>
-                      <a:prstGeom prst="rect">
-                        <a:avLst/>
-                      </a:prstGeom>
-                      <a:noFill/>
-                      <a:ln>
+                      </p:spPr>
+                    </p:pic>
+                  </p:oleObj>
+                </mc:Fallback>
+              </mc:AlternateContent>
+            </a:graphicData>
+          </a:graphic>
+        </p:graphicFrame>
+        <p:graphicFrame>
+          <p:nvGraphicFramePr>
+            <p:cNvPr id="5130" name="Object 10">
+              <a:extLst>
+                <a:ext uri="{FF2B5EF4-FFF2-40B4-BE49-F238E27FC236}">
+                  <a16:creationId xmlns:a16="http://schemas.microsoft.com/office/drawing/2014/main" id="{C02B6EEF-07F3-45B3-AD95-23D93F0D93A0}"/>
+                </a:ext>
+              </a:extLst>
+            </p:cNvPr>
+            <p:cNvGraphicFramePr>
+              <a:graphicFrameLocks noChangeAspect="1"/>
+            </p:cNvGraphicFramePr>
+            <p:nvPr>
+              <p:extLst>
+                <p:ext uri="{D42A27DB-BD31-4B8C-83A1-F6EECF244321}">
+                  <p14:modId xmlns:p14="http://schemas.microsoft.com/office/powerpoint/2010/main" val="995066131"/>
+                </p:ext>
+              </p:extLst>
+            </p:nvPr>
+          </p:nvGraphicFramePr>
+          <p:xfrm>
+            <a:off x="4648200" y="4953000"/>
+            <a:ext cx="3200400" cy="1663700"/>
+          </p:xfrm>
+          <a:graphic>
+            <a:graphicData uri="http://schemas.openxmlformats.org/presentationml/2006/ole">
+              <mc:AlternateContent xmlns:mc="http://schemas.openxmlformats.org/markup-compatibility/2006">
+                <mc:Choice xmlns:v="urn:schemas-microsoft-com:vml" Requires="v">
+                  <p:oleObj name="Equation" r:id="rId12" imgW="1270000" imgH="660400" progId="Equation.DSMT36">
+                    <p:embed/>
+                  </p:oleObj>
+                </mc:Choice>
+                <mc:Fallback>
+                  <p:oleObj name="Equation" r:id="rId12" imgW="1270000" imgH="660400" progId="Equation.DSMT36">
+                    <p:embed/>
+                    <p:pic>
+                      <p:nvPicPr>
+                        <p:cNvPr id="0" name="Object 10"/>
+                        <p:cNvPicPr>
+                          <a:picLocks noChangeAspect="1" noChangeArrowheads="1"/>
+                        </p:cNvPicPr>
+                        <p:nvPr/>
+                      </p:nvPicPr>
+                      <p:blipFill>
+                        <a:blip r:embed="rId13">
+                          <a:extLst>
+                            <a:ext uri="{28A0092B-C50C-407E-A947-70E740481C1C}">
+                              <a14:useLocalDpi xmlns:a14="http://schemas.microsoft.com/office/drawing/2010/main" val="0"/>
+                            </a:ext>
+                          </a:extLst>
+                        </a:blip>
+                        <a:srcRect/>
+                        <a:stretch>
+                          <a:fillRect/>
+                        </a:stretch>
+                      </p:blipFill>
+                      <p:spPr bwMode="auto">
+                        <a:xfrm>
+                          <a:off x="4648200" y="4953000"/>
+                          <a:ext cx="3200400" cy="1663700"/>
+                        </a:xfrm>
+                        <a:prstGeom prst="rect">
+                          <a:avLst/>
+                        </a:prstGeom>
                         <a:noFill/>
-                      </a:ln>
-                      <a:effectLst/>
-                      <a:extLst>
-                        <a:ext uri="{909E8E84-426E-40DD-AFC4-6F175D3DCCD1}">
-                          <a14:hiddenFill xmlns:a14="http://schemas.microsoft.com/office/drawing/2010/main">
-                            <a:solidFill>
-                              <a:schemeClr val="accent1"/>
-                            </a:solidFill>
-                          </a14:hiddenFill>
-                        </a:ext>
-                        <a:ext uri="{91240B29-F687-4F45-9708-019B960494DF}">
-                          <a14:hiddenLine xmlns:a14="http://schemas.microsoft.com/office/drawing/2010/main" w="9525">
-                            <a:solidFill>
-                              <a:schemeClr val="tx1"/>
-                            </a:solidFill>
-                            <a:miter lim="800000"/>
-                            <a:headEnd/>
-                            <a:tailEnd/>
-                          </a14:hiddenLine>
-                        </a:ext>
-                        <a:ext uri="{AF507438-7753-43E0-B8FC-AC1667EBCBE1}">
-                          <a14:hiddenEffects xmlns:a14="http://schemas.microsoft.com/office/drawing/2010/main">
-                            <a:effectLst>
-                              <a:outerShdw dist="35921" dir="2700000" algn="ctr" rotWithShape="0">
-                                <a:schemeClr val="bg2"/>
-                              </a:outerShdw>
-                            </a:effectLst>
-                          </a14:hiddenEffects>
-                        </a:ext>
-                      </a:extLst>
-                    </p:spPr>
-                  </p:pic>
-                </p:oleObj>
-              </mc:Fallback>
-            </mc:AlternateContent>
-          </a:graphicData>
-        </a:graphic>
-      </p:graphicFrame>
-      <p:graphicFrame>
-        <p:nvGraphicFramePr>
-          <p:cNvPr id="5130" name="Object 10">
-            <a:extLst>
-              <a:ext uri="{FF2B5EF4-FFF2-40B4-BE49-F238E27FC236}">
-                <a16:creationId xmlns:a16="http://schemas.microsoft.com/office/drawing/2014/main" id="{C02B6EEF-07F3-45B3-AD95-23D93F0D93A0}"/>
-              </a:ext>
-            </a:extLst>
-          </p:cNvPr>
-          <p:cNvGraphicFramePr>
-            <a:graphicFrameLocks noChangeAspect="1"/>
-          </p:cNvGraphicFramePr>
-          <p:nvPr/>
-        </p:nvGraphicFramePr>
-        <p:xfrm>
-          <a:off x="4648200" y="4953000"/>
-          <a:ext cx="3200400" cy="1663700"/>
-        </p:xfrm>
-        <a:graphic>
-          <a:graphicData uri="http://schemas.openxmlformats.org/presentationml/2006/ole">
-            <mc:AlternateContent xmlns:mc="http://schemas.openxmlformats.org/markup-compatibility/2006">
-              <mc:Choice xmlns:v="urn:schemas-microsoft-com:vml" Requires="v">
-                <p:oleObj name="Equation" r:id="rId12" imgW="1270000" imgH="660400" progId="Equation.DSMT36">
-                  <p:embed/>
-                </p:oleObj>
-              </mc:Choice>
-              <mc:Fallback>
-                <p:oleObj name="Equation" r:id="rId12" imgW="1270000" imgH="660400" progId="Equation.DSMT36">
-                  <p:embed/>
-                  <p:pic>
-                    <p:nvPicPr>
-                      <p:cNvPr id="0" name="Object 10"/>
-                      <p:cNvPicPr>
-                        <a:picLocks noChangeAspect="1" noChangeArrowheads="1"/>
-                      </p:cNvPicPr>
-                      <p:nvPr/>
-                    </p:nvPicPr>
-                    <p:blipFill>
-                      <a:blip r:embed="rId13">
+                        <a:ln>
+                          <a:noFill/>
+                        </a:ln>
+                        <a:effectLst/>
                         <a:extLst>
-                          <a:ext uri="{28A0092B-C50C-407E-A947-70E740481C1C}">
-                            <a14:useLocalDpi xmlns:a14="http://schemas.microsoft.com/office/drawing/2010/main" val="0"/>
+                          <a:ext uri="{909E8E84-426E-40DD-AFC4-6F175D3DCCD1}">
+                            <a14:hiddenFill xmlns:a14="http://schemas.microsoft.com/office/drawing/2010/main">
+                              <a:solidFill>
+                                <a:srgbClr val="FFFFFF"/>
+                              </a:solidFill>
+                            </a14:hiddenFill>
+                          </a:ext>
+                          <a:ext uri="{91240B29-F687-4F45-9708-019B960494DF}">
+                            <a14:hiddenLine xmlns:a14="http://schemas.microsoft.com/office/drawing/2010/main" w="9525">
+                              <a:solidFill>
+                                <a:srgbClr val="000000"/>
+                              </a:solidFill>
+                              <a:miter lim="800000"/>
+                              <a:headEnd/>
+                              <a:tailEnd/>
+                            </a14:hiddenLine>
+                          </a:ext>
+                          <a:ext uri="{AF507438-7753-43E0-B8FC-AC1667EBCBE1}">
+                            <a14:hiddenEffects xmlns:a14="http://schemas.microsoft.com/office/drawing/2010/main">
+                              <a:effectLst>
+                                <a:outerShdw dist="35921" dir="2700000" algn="ctr" rotWithShape="0">
+                                  <a:srgbClr val="808080"/>
+                                </a:outerShdw>
+                              </a:effectLst>
+                            </a14:hiddenEffects>
                           </a:ext>
                         </a:extLst>
-                      </a:blip>
-                      <a:srcRect/>
-                      <a:stretch>
-                        <a:fillRect/>
-                      </a:stretch>
-                    </p:blipFill>
-                    <p:spPr bwMode="auto">
-                      <a:xfrm>
-                        <a:off x="4648200" y="4953000"/>
-                        <a:ext cx="3200400" cy="1663700"/>
-                      </a:xfrm>
-                      <a:prstGeom prst="rect">
-                        <a:avLst/>
-                      </a:prstGeom>
-                      <a:noFill/>
-                      <a:ln>
-                        <a:noFill/>
-                      </a:ln>
-                      <a:effectLst/>
-                      <a:extLst>
-                        <a:ext uri="{909E8E84-426E-40DD-AFC4-6F175D3DCCD1}">
-                          <a14:hiddenFill xmlns:a14="http://schemas.microsoft.com/office/drawing/2010/main">
-                            <a:solidFill>
-                              <a:srgbClr val="FFFFFF"/>
-                            </a:solidFill>
-                          </a14:hiddenFill>
-                        </a:ext>
-                        <a:ext uri="{91240B29-F687-4F45-9708-019B960494DF}">
-                          <a14:hiddenLine xmlns:a14="http://schemas.microsoft.com/office/drawing/2010/main" w="9525">
-                            <a:solidFill>
-                              <a:srgbClr val="000000"/>
-                            </a:solidFill>
-                            <a:miter lim="800000"/>
-                            <a:headEnd/>
-                            <a:tailEnd/>
-                          </a14:hiddenLine>
-                        </a:ext>
-                        <a:ext uri="{AF507438-7753-43E0-B8FC-AC1667EBCBE1}">
-                          <a14:hiddenEffects xmlns:a14="http://schemas.microsoft.com/office/drawing/2010/main">
-                            <a:effectLst>
-                              <a:outerShdw dist="35921" dir="2700000" algn="ctr" rotWithShape="0">
-                                <a:srgbClr val="808080"/>
-                              </a:outerShdw>
-                            </a:effectLst>
-                          </a14:hiddenEffects>
-                        </a:ext>
-                      </a:extLst>
-                    </p:spPr>
-                  </p:pic>
-                </p:oleObj>
-              </mc:Fallback>
-            </mc:AlternateContent>
-          </a:graphicData>
-        </a:graphic>
-      </p:graphicFrame>
+                      </p:spPr>
+                    </p:pic>
+                  </p:oleObj>
+                </mc:Fallback>
+              </mc:AlternateContent>
+            </a:graphicData>
+          </a:graphic>
+        </p:graphicFrame>
+      </p:grpSp>
     </p:spTree>
   </p:cSld>
   <p:clrMapOvr>
@@ -4495,19 +4594,19 @@
               <p:cTn id="2" dur="indefinite" nodeType="mainSeq">
                 <p:childTnLst>
                   <p:par>
-                    <p:cTn id="3" fill="hold" nodeType="clickPar">
+                    <p:cTn id="3" fill="hold">
                       <p:stCondLst>
                         <p:cond delay="indefinite"/>
                       </p:stCondLst>
                       <p:childTnLst>
                         <p:par>
-                          <p:cTn id="4" fill="hold" nodeType="withGroup">
+                          <p:cTn id="4" fill="hold">
                             <p:stCondLst>
                               <p:cond delay="0"/>
                             </p:stCondLst>
                             <p:childTnLst>
                               <p:par>
-                                <p:cTn id="5" presetID="2" presetClass="entr" presetSubtype="8" fill="hold" nodeType="clickEffect">
+                                <p:cTn id="5" presetID="1" presetClass="entr" presetSubtype="0" fill="hold" nodeType="clickEffect">
                                   <p:stCondLst>
                                     <p:cond delay="0"/>
                                   </p:stCondLst>
@@ -4520,7 +4619,105 @@
                                           </p:stCondLst>
                                         </p:cTn>
                                         <p:tgtEl>
-                                          <p:spTgt spid="5124"/>
+                                          <p:spTgt spid="2"/>
+                                        </p:tgtEl>
+                                        <p:attrNameLst>
+                                          <p:attrName>style.visibility</p:attrName>
+                                        </p:attrNameLst>
+                                      </p:cBhvr>
+                                      <p:to>
+                                        <p:strVal val="visible"/>
+                                      </p:to>
+                                    </p:set>
+                                  </p:childTnLst>
+                                </p:cTn>
+                              </p:par>
+                            </p:childTnLst>
+                          </p:cTn>
+                        </p:par>
+                      </p:childTnLst>
+                    </p:cTn>
+                  </p:par>
+                  <p:par>
+                    <p:cTn id="7" fill="hold">
+                      <p:stCondLst>
+                        <p:cond delay="indefinite"/>
+                      </p:stCondLst>
+                      <p:childTnLst>
+                        <p:par>
+                          <p:cTn id="8" fill="hold">
+                            <p:stCondLst>
+                              <p:cond delay="0"/>
+                            </p:stCondLst>
+                            <p:childTnLst>
+                              <p:par>
+                                <p:cTn id="9" presetID="10" presetClass="entr" presetSubtype="0" fill="hold" nodeType="clickEffect">
+                                  <p:stCondLst>
+                                    <p:cond delay="0"/>
+                                  </p:stCondLst>
+                                  <p:childTnLst>
+                                    <p:set>
+                                      <p:cBhvr>
+                                        <p:cTn id="10" dur="1" fill="hold">
+                                          <p:stCondLst>
+                                            <p:cond delay="0"/>
+                                          </p:stCondLst>
+                                        </p:cTn>
+                                        <p:tgtEl>
+                                          <p:spTgt spid="3"/>
+                                        </p:tgtEl>
+                                        <p:attrNameLst>
+                                          <p:attrName>style.visibility</p:attrName>
+                                        </p:attrNameLst>
+                                      </p:cBhvr>
+                                      <p:to>
+                                        <p:strVal val="visible"/>
+                                      </p:to>
+                                    </p:set>
+                                    <p:animEffect transition="in" filter="fade">
+                                      <p:cBhvr>
+                                        <p:cTn id="11" dur="500"/>
+                                        <p:tgtEl>
+                                          <p:spTgt spid="3"/>
+                                        </p:tgtEl>
+                                      </p:cBhvr>
+                                    </p:animEffect>
+                                  </p:childTnLst>
+                                </p:cTn>
+                              </p:par>
+                            </p:childTnLst>
+                          </p:cTn>
+                        </p:par>
+                      </p:childTnLst>
+                    </p:cTn>
+                  </p:par>
+                  <p:par>
+                    <p:cTn id="12" fill="hold">
+                      <p:stCondLst>
+                        <p:cond delay="indefinite"/>
+                      </p:stCondLst>
+                      <p:childTnLst>
+                        <p:par>
+                          <p:cTn id="13" fill="hold">
+                            <p:stCondLst>
+                              <p:cond delay="0"/>
+                            </p:stCondLst>
+                            <p:childTnLst>
+                              <p:par>
+                                <p:cTn id="14" presetID="2" presetClass="entr" presetSubtype="4" fill="hold" nodeType="clickEffect">
+                                  <p:stCondLst>
+                                    <p:cond delay="0"/>
+                                  </p:stCondLst>
+                                  <p:childTnLst>
+                                    <p:set>
+                                      <p:cBhvr>
+                                        <p:cTn id="15" dur="1" fill="hold">
+                                          <p:stCondLst>
+                                            <p:cond delay="0"/>
+                                          </p:stCondLst>
+                                        </p:cTn>
+                                        <p:tgtEl>
+                                          <p:spTgt spid="4"/>
                                         </p:tgtEl>
                                         <p:attrNameLst>
                                           <p:attrName>style.visibility</p:attrName>
@@ -4532,9 +4729,9 @@
                                     </p:set>
                                     <p:anim calcmode="lin" valueType="num">
                                       <p:cBhvr additive="base">
-                                        <p:cTn id="7" dur="500" fill="hold"/>
+                                        <p:cTn id="16" dur="500" fill="hold"/>
                                         <p:tgtEl>
-                                          <p:spTgt spid="5124"/>
+                                          <p:spTgt spid="4"/>
                                         </p:tgtEl>
                                         <p:attrNameLst>
                                           <p:attrName>ppt_x</p:attrName>
@@ -4543,7 +4740,7 @@
                                       <p:tavLst>
                                         <p:tav tm="0">
                                           <p:val>
-                                            <p:strVal val="0-#ppt_w/2"/>
+                                            <p:strVal val="#ppt_x"/>
                                           </p:val>
                                         </p:tav>
                                         <p:tav tm="100000">
@@ -4555,9 +4752,9 @@
                                     </p:anim>
                                     <p:anim calcmode="lin" valueType="num">
                                       <p:cBhvr additive="base">
-                                        <p:cTn id="8" dur="500" fill="hold"/>
+                                        <p:cTn id="17" dur="500" fill="hold"/>
                                         <p:tgtEl>
-                                          <p:spTgt spid="5124"/>
+                                          <p:spTgt spid="4"/>
                                         </p:tgtEl>
                                         <p:attrNameLst>
                                           <p:attrName>ppt_y</p:attrName>
@@ -4566,462 +4763,7 @@
                                       <p:tavLst>
                                         <p:tav tm="0">
                                           <p:val>
-                                            <p:strVal val="#ppt_y"/>
-                                          </p:val>
-                                        </p:tav>
-                                        <p:tav tm="100000">
-                                          <p:val>
-                                            <p:strVal val="#ppt_y"/>
-                                          </p:val>
-                                        </p:tav>
-                                      </p:tavLst>
-                                    </p:anim>
-                                  </p:childTnLst>
-                                </p:cTn>
-                              </p:par>
-                            </p:childTnLst>
-                          </p:cTn>
-                        </p:par>
-                      </p:childTnLst>
-                    </p:cTn>
-                  </p:par>
-                  <p:par>
-                    <p:cTn id="9" fill="hold" nodeType="clickPar">
-                      <p:stCondLst>
-                        <p:cond delay="indefinite"/>
-                      </p:stCondLst>
-                      <p:childTnLst>
-                        <p:par>
-                          <p:cTn id="10" fill="hold" nodeType="withGroup">
-                            <p:stCondLst>
-                              <p:cond delay="0"/>
-                            </p:stCondLst>
-                            <p:childTnLst>
-                              <p:par>
-                                <p:cTn id="11" presetID="2" presetClass="entr" presetSubtype="2" fill="hold" nodeType="clickEffect">
-                                  <p:stCondLst>
-                                    <p:cond delay="0"/>
-                                  </p:stCondLst>
-                                  <p:childTnLst>
-                                    <p:set>
-                                      <p:cBhvr>
-                                        <p:cTn id="12" dur="1" fill="hold">
-                                          <p:stCondLst>
-                                            <p:cond delay="0"/>
-                                          </p:stCondLst>
-                                        </p:cTn>
-                                        <p:tgtEl>
-                                          <p:spTgt spid="5126"/>
-                                        </p:tgtEl>
-                                        <p:attrNameLst>
-                                          <p:attrName>style.visibility</p:attrName>
-                                        </p:attrNameLst>
-                                      </p:cBhvr>
-                                      <p:to>
-                                        <p:strVal val="visible"/>
-                                      </p:to>
-                                    </p:set>
-                                    <p:anim calcmode="lin" valueType="num">
-                                      <p:cBhvr additive="base">
-                                        <p:cTn id="13" dur="500" fill="hold"/>
-                                        <p:tgtEl>
-                                          <p:spTgt spid="5126"/>
-                                        </p:tgtEl>
-                                        <p:attrNameLst>
-                                          <p:attrName>ppt_x</p:attrName>
-                                        </p:attrNameLst>
-                                      </p:cBhvr>
-                                      <p:tavLst>
-                                        <p:tav tm="0">
-                                          <p:val>
-                                            <p:strVal val="1+#ppt_w/2"/>
-                                          </p:val>
-                                        </p:tav>
-                                        <p:tav tm="100000">
-                                          <p:val>
-                                            <p:strVal val="#ppt_x"/>
-                                          </p:val>
-                                        </p:tav>
-                                      </p:tavLst>
-                                    </p:anim>
-                                    <p:anim calcmode="lin" valueType="num">
-                                      <p:cBhvr additive="base">
-                                        <p:cTn id="14" dur="500" fill="hold"/>
-                                        <p:tgtEl>
-                                          <p:spTgt spid="5126"/>
-                                        </p:tgtEl>
-                                        <p:attrNameLst>
-                                          <p:attrName>ppt_y</p:attrName>
-                                        </p:attrNameLst>
-                                      </p:cBhvr>
-                                      <p:tavLst>
-                                        <p:tav tm="0">
-                                          <p:val>
-                                            <p:strVal val="#ppt_y"/>
-                                          </p:val>
-                                        </p:tav>
-                                        <p:tav tm="100000">
-                                          <p:val>
-                                            <p:strVal val="#ppt_y"/>
-                                          </p:val>
-                                        </p:tav>
-                                      </p:tavLst>
-                                    </p:anim>
-                                  </p:childTnLst>
-                                </p:cTn>
-                              </p:par>
-                            </p:childTnLst>
-                          </p:cTn>
-                        </p:par>
-                      </p:childTnLst>
-                    </p:cTn>
-                  </p:par>
-                  <p:par>
-                    <p:cTn id="15" fill="hold" nodeType="clickPar">
-                      <p:stCondLst>
-                        <p:cond delay="indefinite"/>
-                      </p:stCondLst>
-                      <p:childTnLst>
-                        <p:par>
-                          <p:cTn id="16" fill="hold" nodeType="withGroup">
-                            <p:stCondLst>
-                              <p:cond delay="0"/>
-                            </p:stCondLst>
-                            <p:childTnLst>
-                              <p:par>
-                                <p:cTn id="17" presetID="2" presetClass="entr" presetSubtype="8" fill="hold" nodeType="clickEffect">
-                                  <p:stCondLst>
-                                    <p:cond delay="0"/>
-                                  </p:stCondLst>
-                                  <p:childTnLst>
-                                    <p:set>
-                                      <p:cBhvr>
-                                        <p:cTn id="18" dur="1" fill="hold">
-                                          <p:stCondLst>
-                                            <p:cond delay="0"/>
-                                          </p:stCondLst>
-                                        </p:cTn>
-                                        <p:tgtEl>
-                                          <p:spTgt spid="5127"/>
-                                        </p:tgtEl>
-                                        <p:attrNameLst>
-                                          <p:attrName>style.visibility</p:attrName>
-                                        </p:attrNameLst>
-                                      </p:cBhvr>
-                                      <p:to>
-                                        <p:strVal val="visible"/>
-                                      </p:to>
-                                    </p:set>
-                                    <p:anim calcmode="lin" valueType="num">
-                                      <p:cBhvr additive="base">
-                                        <p:cTn id="19" dur="500" fill="hold"/>
-                                        <p:tgtEl>
-                                          <p:spTgt spid="5127"/>
-                                        </p:tgtEl>
-                                        <p:attrNameLst>
-                                          <p:attrName>ppt_x</p:attrName>
-                                        </p:attrNameLst>
-                                      </p:cBhvr>
-                                      <p:tavLst>
-                                        <p:tav tm="0">
-                                          <p:val>
-                                            <p:strVal val="0-#ppt_w/2"/>
-                                          </p:val>
-                                        </p:tav>
-                                        <p:tav tm="100000">
-                                          <p:val>
-                                            <p:strVal val="#ppt_x"/>
-                                          </p:val>
-                                        </p:tav>
-                                      </p:tavLst>
-                                    </p:anim>
-                                    <p:anim calcmode="lin" valueType="num">
-                                      <p:cBhvr additive="base">
-                                        <p:cTn id="20" dur="500" fill="hold"/>
-                                        <p:tgtEl>
-                                          <p:spTgt spid="5127"/>
-                                        </p:tgtEl>
-                                        <p:attrNameLst>
-                                          <p:attrName>ppt_y</p:attrName>
-                                        </p:attrNameLst>
-                                      </p:cBhvr>
-                                      <p:tavLst>
-                                        <p:tav tm="0">
-                                          <p:val>
-                                            <p:strVal val="#ppt_y"/>
-                                          </p:val>
-                                        </p:tav>
-                                        <p:tav tm="100000">
-                                          <p:val>
-                                            <p:strVal val="#ppt_y"/>
-                                          </p:val>
-                                        </p:tav>
-                                      </p:tavLst>
-                                    </p:anim>
-                                  </p:childTnLst>
-                                </p:cTn>
-                              </p:par>
-                            </p:childTnLst>
-                          </p:cTn>
-                        </p:par>
-                      </p:childTnLst>
-                    </p:cTn>
-                  </p:par>
-                  <p:par>
-                    <p:cTn id="21" fill="hold" nodeType="clickPar">
-                      <p:stCondLst>
-                        <p:cond delay="indefinite"/>
-                      </p:stCondLst>
-                      <p:childTnLst>
-                        <p:par>
-                          <p:cTn id="22" fill="hold" nodeType="withGroup">
-                            <p:stCondLst>
-                              <p:cond delay="0"/>
-                            </p:stCondLst>
-                            <p:childTnLst>
-                              <p:par>
-                                <p:cTn id="23" presetID="2" presetClass="entr" presetSubtype="2" fill="hold" nodeType="clickEffect">
-                                  <p:stCondLst>
-                                    <p:cond delay="0"/>
-                                  </p:stCondLst>
-                                  <p:childTnLst>
-                                    <p:set>
-                                      <p:cBhvr>
-                                        <p:cTn id="24" dur="1" fill="hold">
-                                          <p:stCondLst>
-                                            <p:cond delay="0"/>
-                                          </p:stCondLst>
-                                        </p:cTn>
-                                        <p:tgtEl>
-                                          <p:spTgt spid="5128"/>
-                                        </p:tgtEl>
-                                        <p:attrNameLst>
-                                          <p:attrName>style.visibility</p:attrName>
-                                        </p:attrNameLst>
-                                      </p:cBhvr>
-                                      <p:to>
-                                        <p:strVal val="visible"/>
-                                      </p:to>
-                                    </p:set>
-                                    <p:anim calcmode="lin" valueType="num">
-                                      <p:cBhvr additive="base">
-                                        <p:cTn id="25" dur="500" fill="hold"/>
-                                        <p:tgtEl>
-                                          <p:spTgt spid="5128"/>
-                                        </p:tgtEl>
-                                        <p:attrNameLst>
-                                          <p:attrName>ppt_x</p:attrName>
-                                        </p:attrNameLst>
-                                      </p:cBhvr>
-                                      <p:tavLst>
-                                        <p:tav tm="0">
-                                          <p:val>
-                                            <p:strVal val="1+#ppt_w/2"/>
-                                          </p:val>
-                                        </p:tav>
-                                        <p:tav tm="100000">
-                                          <p:val>
-                                            <p:strVal val="#ppt_x"/>
-                                          </p:val>
-                                        </p:tav>
-                                      </p:tavLst>
-                                    </p:anim>
-                                    <p:anim calcmode="lin" valueType="num">
-                                      <p:cBhvr additive="base">
-                                        <p:cTn id="26" dur="500" fill="hold"/>
-                                        <p:tgtEl>
-                                          <p:spTgt spid="5128"/>
-                                        </p:tgtEl>
-                                        <p:attrNameLst>
-                                          <p:attrName>ppt_y</p:attrName>
-                                        </p:attrNameLst>
-                                      </p:cBhvr>
-                                      <p:tavLst>
-                                        <p:tav tm="0">
-                                          <p:val>
-                                            <p:strVal val="#ppt_y"/>
-                                          </p:val>
-                                        </p:tav>
-                                        <p:tav tm="100000">
-                                          <p:val>
-                                            <p:strVal val="#ppt_y"/>
-                                          </p:val>
-                                        </p:tav>
-                                      </p:tavLst>
-                                    </p:anim>
-                                  </p:childTnLst>
-                                </p:cTn>
-                              </p:par>
-                            </p:childTnLst>
-                          </p:cTn>
-                        </p:par>
-                      </p:childTnLst>
-                    </p:cTn>
-                  </p:par>
-                  <p:par>
-                    <p:cTn id="27" fill="hold" nodeType="clickPar">
-                      <p:stCondLst>
-                        <p:cond delay="indefinite"/>
-                      </p:stCondLst>
-                      <p:childTnLst>
-                        <p:par>
-                          <p:cTn id="28" fill="hold" nodeType="withGroup">
-                            <p:stCondLst>
-                              <p:cond delay="0"/>
-                            </p:stCondLst>
-                            <p:childTnLst>
-                              <p:par>
-                                <p:cTn id="29" presetID="2" presetClass="entr" presetSubtype="8" fill="hold" nodeType="clickEffect">
-                                  <p:stCondLst>
-                                    <p:cond delay="0"/>
-                                  </p:stCondLst>
-                                  <p:childTnLst>
-                                    <p:set>
-                                      <p:cBhvr>
-                                        <p:cTn id="30" dur="1" fill="hold">
-                                          <p:stCondLst>
-                                            <p:cond delay="0"/>
-                                          </p:stCondLst>
-                                        </p:cTn>
-                                        <p:tgtEl>
-                                          <p:spTgt spid="5129"/>
-                                        </p:tgtEl>
-                                        <p:attrNameLst>
-                                          <p:attrName>style.visibility</p:attrName>
-                                        </p:attrNameLst>
-                                      </p:cBhvr>
-                                      <p:to>
-                                        <p:strVal val="visible"/>
-                                      </p:to>
-                                    </p:set>
-                                    <p:anim calcmode="lin" valueType="num">
-                                      <p:cBhvr additive="base">
-                                        <p:cTn id="31" dur="500" fill="hold"/>
-                                        <p:tgtEl>
-                                          <p:spTgt spid="5129"/>
-                                        </p:tgtEl>
-                                        <p:attrNameLst>
-                                          <p:attrName>ppt_x</p:attrName>
-                                        </p:attrNameLst>
-                                      </p:cBhvr>
-                                      <p:tavLst>
-                                        <p:tav tm="0">
-                                          <p:val>
-                                            <p:strVal val="0-#ppt_w/2"/>
-                                          </p:val>
-                                        </p:tav>
-                                        <p:tav tm="100000">
-                                          <p:val>
-                                            <p:strVal val="#ppt_x"/>
-                                          </p:val>
-                                        </p:tav>
-                                      </p:tavLst>
-                                    </p:anim>
-                                    <p:anim calcmode="lin" valueType="num">
-                                      <p:cBhvr additive="base">
-                                        <p:cTn id="32" dur="500" fill="hold"/>
-                                        <p:tgtEl>
-                                          <p:spTgt spid="5129"/>
-                                        </p:tgtEl>
-                                        <p:attrNameLst>
-                                          <p:attrName>ppt_y</p:attrName>
-                                        </p:attrNameLst>
-                                      </p:cBhvr>
-                                      <p:tavLst>
-                                        <p:tav tm="0">
-                                          <p:val>
-                                            <p:strVal val="#ppt_y"/>
-                                          </p:val>
-                                        </p:tav>
-                                        <p:tav tm="100000">
-                                          <p:val>
-                                            <p:strVal val="#ppt_y"/>
-                                          </p:val>
-                                        </p:tav>
-                                      </p:tavLst>
-                                    </p:anim>
-                                  </p:childTnLst>
-                                </p:cTn>
-                              </p:par>
-                            </p:childTnLst>
-                          </p:cTn>
-                        </p:par>
-                      </p:childTnLst>
-                    </p:cTn>
-                  </p:par>
-                  <p:par>
-                    <p:cTn id="33" fill="hold" nodeType="clickPar">
-                      <p:stCondLst>
-                        <p:cond delay="indefinite"/>
-                      </p:stCondLst>
-                      <p:childTnLst>
-                        <p:par>
-                          <p:cTn id="34" fill="hold" nodeType="withGroup">
-                            <p:stCondLst>
-                              <p:cond delay="0"/>
-                            </p:stCondLst>
-                            <p:childTnLst>
-                              <p:par>
-                                <p:cTn id="35" presetID="2" presetClass="entr" presetSubtype="2" fill="hold" nodeType="clickEffect">
-                                  <p:stCondLst>
-                                    <p:cond delay="0"/>
-                                  </p:stCondLst>
-                                  <p:childTnLst>
-                                    <p:set>
-                                      <p:cBhvr>
-                                        <p:cTn id="36" dur="1" fill="hold">
-                                          <p:stCondLst>
-                                            <p:cond delay="0"/>
-                                          </p:stCondLst>
-                                        </p:cTn>
-                                        <p:tgtEl>
-                                          <p:spTgt spid="5130"/>
-                                        </p:tgtEl>
-                                        <p:attrNameLst>
-                                          <p:attrName>style.visibility</p:attrName>
-                                        </p:attrNameLst>
-                                      </p:cBhvr>
-                                      <p:to>
-                                        <p:strVal val="visible"/>
-                                      </p:to>
-                                    </p:set>
-                                    <p:anim calcmode="lin" valueType="num">
-                                      <p:cBhvr additive="base">
-                                        <p:cTn id="37" dur="500" fill="hold"/>
-                                        <p:tgtEl>
-                                          <p:spTgt spid="5130"/>
-                                        </p:tgtEl>
-                                        <p:attrNameLst>
-                                          <p:attrName>ppt_x</p:attrName>
-                                        </p:attrNameLst>
-                                      </p:cBhvr>
-                                      <p:tavLst>
-                                        <p:tav tm="0">
-                                          <p:val>
-                                            <p:strVal val="1+#ppt_w/2"/>
-                                          </p:val>
-                                        </p:tav>
-                                        <p:tav tm="100000">
-                                          <p:val>
-                                            <p:strVal val="#ppt_x"/>
-                                          </p:val>
-                                        </p:tav>
-                                      </p:tavLst>
-                                    </p:anim>
-                                    <p:anim calcmode="lin" valueType="num">
-                                      <p:cBhvr additive="base">
-                                        <p:cTn id="38" dur="500" fill="hold"/>
-                                        <p:tgtEl>
-                                          <p:spTgt spid="5130"/>
-                                        </p:tgtEl>
-                                        <p:attrNameLst>
-                                          <p:attrName>ppt_y</p:attrName>
-                                        </p:attrNameLst>
-                                      </p:cBhvr>
-                                      <p:tavLst>
-                                        <p:tav tm="0">
-                                          <p:val>
-                                            <p:strVal val="#ppt_y"/>
+                                            <p:strVal val="1+#ppt_h/2"/>
                                           </p:val>
                                         </p:tav>
                                         <p:tav tm="100000">
@@ -6081,586 +5823,6 @@
   <p:clrMapOvr>
     <a:masterClrMapping/>
   </p:clrMapOvr>
-  <p:timing>
-    <p:tnLst>
-      <p:par>
-        <p:cTn id="1" dur="indefinite" restart="never" nodeType="tmRoot">
-          <p:childTnLst>
-            <p:seq concurrent="1" nextAc="seek">
-              <p:cTn id="2" dur="indefinite" nodeType="mainSeq">
-                <p:childTnLst>
-                  <p:par>
-                    <p:cTn id="3" fill="hold" nodeType="clickPar">
-                      <p:stCondLst>
-                        <p:cond delay="indefinite"/>
-                      </p:stCondLst>
-                      <p:childTnLst>
-                        <p:par>
-                          <p:cTn id="4" fill="hold" nodeType="withGroup">
-                            <p:stCondLst>
-                              <p:cond delay="0"/>
-                            </p:stCondLst>
-                            <p:childTnLst>
-                              <p:par>
-                                <p:cTn id="5" presetID="2" presetClass="entr" presetSubtype="8" fill="hold" nodeType="clickEffect">
-                                  <p:stCondLst>
-                                    <p:cond delay="0"/>
-                                  </p:stCondLst>
-                                  <p:childTnLst>
-                                    <p:set>
-                                      <p:cBhvr>
-                                        <p:cTn id="6" dur="1" fill="hold">
-                                          <p:stCondLst>
-                                            <p:cond delay="0"/>
-                                          </p:stCondLst>
-                                        </p:cTn>
-                                        <p:tgtEl>
-                                          <p:spTgt spid="7171"/>
-                                        </p:tgtEl>
-                                        <p:attrNameLst>
-                                          <p:attrName>style.visibility</p:attrName>
-                                        </p:attrNameLst>
-                                      </p:cBhvr>
-                                      <p:to>
-                                        <p:strVal val="visible"/>
-                                      </p:to>
-                                    </p:set>
-                                    <p:anim calcmode="lin" valueType="num">
-                                      <p:cBhvr additive="base">
-                                        <p:cTn id="7" dur="500" fill="hold"/>
-                                        <p:tgtEl>
-                                          <p:spTgt spid="7171"/>
-                                        </p:tgtEl>
-                                        <p:attrNameLst>
-                                          <p:attrName>ppt_x</p:attrName>
-                                        </p:attrNameLst>
-                                      </p:cBhvr>
-                                      <p:tavLst>
-                                        <p:tav tm="0">
-                                          <p:val>
-                                            <p:strVal val="0-#ppt_w/2"/>
-                                          </p:val>
-                                        </p:tav>
-                                        <p:tav tm="100000">
-                                          <p:val>
-                                            <p:strVal val="#ppt_x"/>
-                                          </p:val>
-                                        </p:tav>
-                                      </p:tavLst>
-                                    </p:anim>
-                                    <p:anim calcmode="lin" valueType="num">
-                                      <p:cBhvr additive="base">
-                                        <p:cTn id="8" dur="500" fill="hold"/>
-                                        <p:tgtEl>
-                                          <p:spTgt spid="7171"/>
-                                        </p:tgtEl>
-                                        <p:attrNameLst>
-                                          <p:attrName>ppt_y</p:attrName>
-                                        </p:attrNameLst>
-                                      </p:cBhvr>
-                                      <p:tavLst>
-                                        <p:tav tm="0">
-                                          <p:val>
-                                            <p:strVal val="#ppt_y"/>
-                                          </p:val>
-                                        </p:tav>
-                                        <p:tav tm="100000">
-                                          <p:val>
-                                            <p:strVal val="#ppt_y"/>
-                                          </p:val>
-                                        </p:tav>
-                                      </p:tavLst>
-                                    </p:anim>
-                                  </p:childTnLst>
-                                </p:cTn>
-                              </p:par>
-                            </p:childTnLst>
-                          </p:cTn>
-                        </p:par>
-                      </p:childTnLst>
-                    </p:cTn>
-                  </p:par>
-                  <p:par>
-                    <p:cTn id="9" fill="hold" nodeType="clickPar">
-                      <p:stCondLst>
-                        <p:cond delay="indefinite"/>
-                      </p:stCondLst>
-                      <p:childTnLst>
-                        <p:par>
-                          <p:cTn id="10" fill="hold" nodeType="withGroup">
-                            <p:stCondLst>
-                              <p:cond delay="0"/>
-                            </p:stCondLst>
-                            <p:childTnLst>
-                              <p:par>
-                                <p:cTn id="11" presetID="2" presetClass="entr" presetSubtype="8" fill="hold" nodeType="clickEffect">
-                                  <p:stCondLst>
-                                    <p:cond delay="0"/>
-                                  </p:stCondLst>
-                                  <p:childTnLst>
-                                    <p:set>
-                                      <p:cBhvr>
-                                        <p:cTn id="12" dur="1" fill="hold">
-                                          <p:stCondLst>
-                                            <p:cond delay="0"/>
-                                          </p:stCondLst>
-                                        </p:cTn>
-                                        <p:tgtEl>
-                                          <p:spTgt spid="7192"/>
-                                        </p:tgtEl>
-                                        <p:attrNameLst>
-                                          <p:attrName>style.visibility</p:attrName>
-                                        </p:attrNameLst>
-                                      </p:cBhvr>
-                                      <p:to>
-                                        <p:strVal val="visible"/>
-                                      </p:to>
-                                    </p:set>
-                                    <p:anim calcmode="lin" valueType="num">
-                                      <p:cBhvr additive="base">
-                                        <p:cTn id="13" dur="500" fill="hold"/>
-                                        <p:tgtEl>
-                                          <p:spTgt spid="7192"/>
-                                        </p:tgtEl>
-                                        <p:attrNameLst>
-                                          <p:attrName>ppt_x</p:attrName>
-                                        </p:attrNameLst>
-                                      </p:cBhvr>
-                                      <p:tavLst>
-                                        <p:tav tm="0">
-                                          <p:val>
-                                            <p:strVal val="0-#ppt_w/2"/>
-                                          </p:val>
-                                        </p:tav>
-                                        <p:tav tm="100000">
-                                          <p:val>
-                                            <p:strVal val="#ppt_x"/>
-                                          </p:val>
-                                        </p:tav>
-                                      </p:tavLst>
-                                    </p:anim>
-                                    <p:anim calcmode="lin" valueType="num">
-                                      <p:cBhvr additive="base">
-                                        <p:cTn id="14" dur="500" fill="hold"/>
-                                        <p:tgtEl>
-                                          <p:spTgt spid="7192"/>
-                                        </p:tgtEl>
-                                        <p:attrNameLst>
-                                          <p:attrName>ppt_y</p:attrName>
-                                        </p:attrNameLst>
-                                      </p:cBhvr>
-                                      <p:tavLst>
-                                        <p:tav tm="0">
-                                          <p:val>
-                                            <p:strVal val="#ppt_y"/>
-                                          </p:val>
-                                        </p:tav>
-                                        <p:tav tm="100000">
-                                          <p:val>
-                                            <p:strVal val="#ppt_y"/>
-                                          </p:val>
-                                        </p:tav>
-                                      </p:tavLst>
-                                    </p:anim>
-                                  </p:childTnLst>
-                                </p:cTn>
-                              </p:par>
-                            </p:childTnLst>
-                          </p:cTn>
-                        </p:par>
-                      </p:childTnLst>
-                    </p:cTn>
-                  </p:par>
-                  <p:par>
-                    <p:cTn id="15" fill="hold" nodeType="clickPar">
-                      <p:stCondLst>
-                        <p:cond delay="indefinite"/>
-                      </p:stCondLst>
-                      <p:childTnLst>
-                        <p:par>
-                          <p:cTn id="16" fill="hold" nodeType="withGroup">
-                            <p:stCondLst>
-                              <p:cond delay="0"/>
-                            </p:stCondLst>
-                            <p:childTnLst>
-                              <p:par>
-                                <p:cTn id="17" presetID="2" presetClass="entr" presetSubtype="8" fill="hold" nodeType="clickEffect">
-                                  <p:stCondLst>
-                                    <p:cond delay="0"/>
-                                  </p:stCondLst>
-                                  <p:childTnLst>
-                                    <p:set>
-                                      <p:cBhvr>
-                                        <p:cTn id="18" dur="1" fill="hold">
-                                          <p:stCondLst>
-                                            <p:cond delay="0"/>
-                                          </p:stCondLst>
-                                        </p:cTn>
-                                        <p:tgtEl>
-                                          <p:spTgt spid="7190"/>
-                                        </p:tgtEl>
-                                        <p:attrNameLst>
-                                          <p:attrName>style.visibility</p:attrName>
-                                        </p:attrNameLst>
-                                      </p:cBhvr>
-                                      <p:to>
-                                        <p:strVal val="visible"/>
-                                      </p:to>
-                                    </p:set>
-                                    <p:anim calcmode="lin" valueType="num">
-                                      <p:cBhvr additive="base">
-                                        <p:cTn id="19" dur="500" fill="hold"/>
-                                        <p:tgtEl>
-                                          <p:spTgt spid="7190"/>
-                                        </p:tgtEl>
-                                        <p:attrNameLst>
-                                          <p:attrName>ppt_x</p:attrName>
-                                        </p:attrNameLst>
-                                      </p:cBhvr>
-                                      <p:tavLst>
-                                        <p:tav tm="0">
-                                          <p:val>
-                                            <p:strVal val="0-#ppt_w/2"/>
-                                          </p:val>
-                                        </p:tav>
-                                        <p:tav tm="100000">
-                                          <p:val>
-                                            <p:strVal val="#ppt_x"/>
-                                          </p:val>
-                                        </p:tav>
-                                      </p:tavLst>
-                                    </p:anim>
-                                    <p:anim calcmode="lin" valueType="num">
-                                      <p:cBhvr additive="base">
-                                        <p:cTn id="20" dur="500" fill="hold"/>
-                                        <p:tgtEl>
-                                          <p:spTgt spid="7190"/>
-                                        </p:tgtEl>
-                                        <p:attrNameLst>
-                                          <p:attrName>ppt_y</p:attrName>
-                                        </p:attrNameLst>
-                                      </p:cBhvr>
-                                      <p:tavLst>
-                                        <p:tav tm="0">
-                                          <p:val>
-                                            <p:strVal val="#ppt_y"/>
-                                          </p:val>
-                                        </p:tav>
-                                        <p:tav tm="100000">
-                                          <p:val>
-                                            <p:strVal val="#ppt_y"/>
-                                          </p:val>
-                                        </p:tav>
-                                      </p:tavLst>
-                                    </p:anim>
-                                  </p:childTnLst>
-                                </p:cTn>
-                              </p:par>
-                            </p:childTnLst>
-                          </p:cTn>
-                        </p:par>
-                      </p:childTnLst>
-                    </p:cTn>
-                  </p:par>
-                  <p:par>
-                    <p:cTn id="21" fill="hold" nodeType="clickPar">
-                      <p:stCondLst>
-                        <p:cond delay="indefinite"/>
-                      </p:stCondLst>
-                      <p:childTnLst>
-                        <p:par>
-                          <p:cTn id="22" fill="hold" nodeType="withGroup">
-                            <p:stCondLst>
-                              <p:cond delay="0"/>
-                            </p:stCondLst>
-                            <p:childTnLst>
-                              <p:par>
-                                <p:cTn id="23" presetID="2" presetClass="entr" presetSubtype="8" fill="hold" grpId="0" nodeType="clickEffect">
-                                  <p:stCondLst>
-                                    <p:cond delay="0"/>
-                                  </p:stCondLst>
-                                  <p:childTnLst>
-                                    <p:set>
-                                      <p:cBhvr>
-                                        <p:cTn id="24" dur="1" fill="hold">
-                                          <p:stCondLst>
-                                            <p:cond delay="0"/>
-                                          </p:stCondLst>
-                                        </p:cTn>
-                                        <p:tgtEl>
-                                          <p:spTgt spid="7179"/>
-                                        </p:tgtEl>
-                                        <p:attrNameLst>
-                                          <p:attrName>style.visibility</p:attrName>
-                                        </p:attrNameLst>
-                                      </p:cBhvr>
-                                      <p:to>
-                                        <p:strVal val="visible"/>
-                                      </p:to>
-                                    </p:set>
-                                    <p:anim calcmode="lin" valueType="num">
-                                      <p:cBhvr additive="base">
-                                        <p:cTn id="25" dur="500" fill="hold"/>
-                                        <p:tgtEl>
-                                          <p:spTgt spid="7179"/>
-                                        </p:tgtEl>
-                                        <p:attrNameLst>
-                                          <p:attrName>ppt_x</p:attrName>
-                                        </p:attrNameLst>
-                                      </p:cBhvr>
-                                      <p:tavLst>
-                                        <p:tav tm="0">
-                                          <p:val>
-                                            <p:strVal val="0-#ppt_w/2"/>
-                                          </p:val>
-                                        </p:tav>
-                                        <p:tav tm="100000">
-                                          <p:val>
-                                            <p:strVal val="#ppt_x"/>
-                                          </p:val>
-                                        </p:tav>
-                                      </p:tavLst>
-                                    </p:anim>
-                                    <p:anim calcmode="lin" valueType="num">
-                                      <p:cBhvr additive="base">
-                                        <p:cTn id="26" dur="500" fill="hold"/>
-                                        <p:tgtEl>
-                                          <p:spTgt spid="7179"/>
-                                        </p:tgtEl>
-                                        <p:attrNameLst>
-                                          <p:attrName>ppt_y</p:attrName>
-                                        </p:attrNameLst>
-                                      </p:cBhvr>
-                                      <p:tavLst>
-                                        <p:tav tm="0">
-                                          <p:val>
-                                            <p:strVal val="#ppt_y"/>
-                                          </p:val>
-                                        </p:tav>
-                                        <p:tav tm="100000">
-                                          <p:val>
-                                            <p:strVal val="#ppt_y"/>
-                                          </p:val>
-                                        </p:tav>
-                                      </p:tavLst>
-                                    </p:anim>
-                                  </p:childTnLst>
-                                </p:cTn>
-                              </p:par>
-                            </p:childTnLst>
-                          </p:cTn>
-                        </p:par>
-                      </p:childTnLst>
-                    </p:cTn>
-                  </p:par>
-                  <p:par>
-                    <p:cTn id="27" fill="hold" nodeType="clickPar">
-                      <p:stCondLst>
-                        <p:cond delay="indefinite"/>
-                      </p:stCondLst>
-                      <p:childTnLst>
-                        <p:par>
-                          <p:cTn id="28" fill="hold" nodeType="withGroup">
-                            <p:stCondLst>
-                              <p:cond delay="0"/>
-                            </p:stCondLst>
-                            <p:childTnLst>
-                              <p:par>
-                                <p:cTn id="29" presetID="2" presetClass="entr" presetSubtype="8" fill="hold" nodeType="clickEffect">
-                                  <p:stCondLst>
-                                    <p:cond delay="0"/>
-                                  </p:stCondLst>
-                                  <p:childTnLst>
-                                    <p:set>
-                                      <p:cBhvr>
-                                        <p:cTn id="30" dur="1" fill="hold">
-                                          <p:stCondLst>
-                                            <p:cond delay="0"/>
-                                          </p:stCondLst>
-                                        </p:cTn>
-                                        <p:tgtEl>
-                                          <p:spTgt spid="7191"/>
-                                        </p:tgtEl>
-                                        <p:attrNameLst>
-                                          <p:attrName>style.visibility</p:attrName>
-                                        </p:attrNameLst>
-                                      </p:cBhvr>
-                                      <p:to>
-                                        <p:strVal val="visible"/>
-                                      </p:to>
-                                    </p:set>
-                                    <p:anim calcmode="lin" valueType="num">
-                                      <p:cBhvr additive="base">
-                                        <p:cTn id="31" dur="500" fill="hold"/>
-                                        <p:tgtEl>
-                                          <p:spTgt spid="7191"/>
-                                        </p:tgtEl>
-                                        <p:attrNameLst>
-                                          <p:attrName>ppt_x</p:attrName>
-                                        </p:attrNameLst>
-                                      </p:cBhvr>
-                                      <p:tavLst>
-                                        <p:tav tm="0">
-                                          <p:val>
-                                            <p:strVal val="0-#ppt_w/2"/>
-                                          </p:val>
-                                        </p:tav>
-                                        <p:tav tm="100000">
-                                          <p:val>
-                                            <p:strVal val="#ppt_x"/>
-                                          </p:val>
-                                        </p:tav>
-                                      </p:tavLst>
-                                    </p:anim>
-                                    <p:anim calcmode="lin" valueType="num">
-                                      <p:cBhvr additive="base">
-                                        <p:cTn id="32" dur="500" fill="hold"/>
-                                        <p:tgtEl>
-                                          <p:spTgt spid="7191"/>
-                                        </p:tgtEl>
-                                        <p:attrNameLst>
-                                          <p:attrName>ppt_y</p:attrName>
-                                        </p:attrNameLst>
-                                      </p:cBhvr>
-                                      <p:tavLst>
-                                        <p:tav tm="0">
-                                          <p:val>
-                                            <p:strVal val="#ppt_y"/>
-                                          </p:val>
-                                        </p:tav>
-                                        <p:tav tm="100000">
-                                          <p:val>
-                                            <p:strVal val="#ppt_y"/>
-                                          </p:val>
-                                        </p:tav>
-                                      </p:tavLst>
-                                    </p:anim>
-                                  </p:childTnLst>
-                                </p:cTn>
-                              </p:par>
-                            </p:childTnLst>
-                          </p:cTn>
-                        </p:par>
-                      </p:childTnLst>
-                    </p:cTn>
-                  </p:par>
-                  <p:par>
-                    <p:cTn id="33" fill="hold" nodeType="clickPar">
-                      <p:stCondLst>
-                        <p:cond delay="indefinite"/>
-                      </p:stCondLst>
-                      <p:childTnLst>
-                        <p:par>
-                          <p:cTn id="34" fill="hold" nodeType="withGroup">
-                            <p:stCondLst>
-                              <p:cond delay="0"/>
-                            </p:stCondLst>
-                            <p:childTnLst>
-                              <p:par>
-                                <p:cTn id="35" presetID="2" presetClass="entr" presetSubtype="8" fill="hold" grpId="0" nodeType="clickEffect">
-                                  <p:stCondLst>
-                                    <p:cond delay="0"/>
-                                  </p:stCondLst>
-                                  <p:childTnLst>
-                                    <p:set>
-                                      <p:cBhvr>
-                                        <p:cTn id="36" dur="1" fill="hold">
-                                          <p:stCondLst>
-                                            <p:cond delay="0"/>
-                                          </p:stCondLst>
-                                        </p:cTn>
-                                        <p:tgtEl>
-                                          <p:spTgt spid="7183"/>
-                                        </p:tgtEl>
-                                        <p:attrNameLst>
-                                          <p:attrName>style.visibility</p:attrName>
-                                        </p:attrNameLst>
-                                      </p:cBhvr>
-                                      <p:to>
-                                        <p:strVal val="visible"/>
-                                      </p:to>
-                                    </p:set>
-                                    <p:anim calcmode="lin" valueType="num">
-                                      <p:cBhvr additive="base">
-                                        <p:cTn id="37" dur="500" fill="hold"/>
-                                        <p:tgtEl>
-                                          <p:spTgt spid="7183"/>
-                                        </p:tgtEl>
-                                        <p:attrNameLst>
-                                          <p:attrName>ppt_x</p:attrName>
-                                        </p:attrNameLst>
-                                      </p:cBhvr>
-                                      <p:tavLst>
-                                        <p:tav tm="0">
-                                          <p:val>
-                                            <p:strVal val="0-#ppt_w/2"/>
-                                          </p:val>
-                                        </p:tav>
-                                        <p:tav tm="100000">
-                                          <p:val>
-                                            <p:strVal val="#ppt_x"/>
-                                          </p:val>
-                                        </p:tav>
-                                      </p:tavLst>
-                                    </p:anim>
-                                    <p:anim calcmode="lin" valueType="num">
-                                      <p:cBhvr additive="base">
-                                        <p:cTn id="38" dur="500" fill="hold"/>
-                                        <p:tgtEl>
-                                          <p:spTgt spid="7183"/>
-                                        </p:tgtEl>
-                                        <p:attrNameLst>
-                                          <p:attrName>ppt_y</p:attrName>
-                                        </p:attrNameLst>
-                                      </p:cBhvr>
-                                      <p:tavLst>
-                                        <p:tav tm="0">
-                                          <p:val>
-                                            <p:strVal val="#ppt_y"/>
-                                          </p:val>
-                                        </p:tav>
-                                        <p:tav tm="100000">
-                                          <p:val>
-                                            <p:strVal val="#ppt_y"/>
-                                          </p:val>
-                                        </p:tav>
-                                      </p:tavLst>
-                                    </p:anim>
-                                  </p:childTnLst>
-                                </p:cTn>
-                              </p:par>
-                            </p:childTnLst>
-                          </p:cTn>
-                        </p:par>
-                      </p:childTnLst>
-                    </p:cTn>
-                  </p:par>
-                </p:childTnLst>
-              </p:cTn>
-              <p:prevCondLst>
-                <p:cond evt="onPrev" delay="0">
-                  <p:tgtEl>
-                    <p:sldTgt/>
-                  </p:tgtEl>
-                </p:cond>
-              </p:prevCondLst>
-              <p:nextCondLst>
-                <p:cond evt="onNext" delay="0">
-                  <p:tgtEl>
-                    <p:sldTgt/>
-                  </p:tgtEl>
-                </p:cond>
-              </p:nextCondLst>
-            </p:seq>
-          </p:childTnLst>
-        </p:cTn>
-      </p:par>
-    </p:tnLst>
-    <p:bldLst>
-      <p:bldP spid="7179" grpId="0" autoUpdateAnimBg="0"/>
-      <p:bldP spid="7183" grpId="0" autoUpdateAnimBg="0"/>
-    </p:bldLst>
-  </p:timing>
 </p:sld>
 </file>
 
@@ -8208,51 +7370,6 @@
                                         </p:cTn>
                                         <p:tgtEl>
                                           <p:spTgt spid="8219"/>
-                                        </p:tgtEl>
-                                        <p:attrNameLst>
-                                          <p:attrName>style.visibility</p:attrName>
-                                        </p:attrNameLst>
-                                      </p:cBhvr>
-                                      <p:to>
-                                        <p:strVal val="visible"/>
-                                      </p:to>
-                                    </p:set>
-                                  </p:childTnLst>
-                                </p:cTn>
-                              </p:par>
-                            </p:childTnLst>
-                          </p:cTn>
-                        </p:par>
-                      </p:childTnLst>
-                    </p:cTn>
-                  </p:par>
-                  <p:par>
-                    <p:cTn id="7" fill="hold" nodeType="clickPar">
-                      <p:stCondLst>
-                        <p:cond delay="indefinite"/>
-                      </p:stCondLst>
-                      <p:childTnLst>
-                        <p:par>
-                          <p:cTn id="8" fill="hold" nodeType="withGroup">
-                            <p:stCondLst>
-                              <p:cond delay="0"/>
-                            </p:stCondLst>
-                            <p:childTnLst>
-                              <p:par>
-                                <p:cTn id="9" presetID="1" presetClass="entr" presetSubtype="0" fill="hold" nodeType="clickEffect">
-                                  <p:stCondLst>
-                                    <p:cond delay="0"/>
-                                  </p:stCondLst>
-                                  <p:childTnLst>
-                                    <p:set>
-                                      <p:cBhvr>
-                                        <p:cTn id="10" dur="1" fill="hold">
-                                          <p:stCondLst>
-                                            <p:cond delay="499"/>
-                                          </p:stCondLst>
-                                        </p:cTn>
-                                        <p:tgtEl>
-                                          <p:spTgt spid="8217"/>
                                         </p:tgtEl>
                                         <p:attrNameLst>
                                           <p:attrName>style.visibility</p:attrName>

</xml_diff>